<commit_message>
docs: fix PPT text visibility, add repo URL, clean up reference docs
- Fix PPT color rendering: rewrite text preserving original solidFill/font
  formatting so text is visible in PowerPoint (was invisible due to missing
  color on new runs)
- Add GitHub repo URL (branch L2) to REFLECTION.md and criteria_checklist.md
- Mark all P1-P14 items complete in criteria_checklist.md with evidence refs
- Remove internal tracking files: pendientes.md, L1 review docx, L2 brief docx
- Add scripts/fix_ppt_colors.py for reproducible PPT text updates

Co-Authored-By: Claude Sonnet 4.6 <noreply@anthropic.com>
</commit_message>
<xml_diff>
--- a/docs/AI_Capstone_L2_Julian Largo.pptx
+++ b/docs/AI_Capstone_L2_Julian Largo.pptx
@@ -5,7 +5,7 @@
     <p:sldMasterId id="2147483648" r:id="rId4"/>
   </p:sldMasterIdLst>
   <p:notesMasterIdLst>
-    <p:notesMasterId r:id="rId18"/>
+    <p:notesMasterId r:id="rId21"/>
   </p:notesMasterIdLst>
   <p:sldIdLst>
     <p:sldId id="256" r:id="rId5"/>
@@ -13,14 +13,17 @@
     <p:sldId id="258" r:id="rId7"/>
     <p:sldId id="259" r:id="rId8"/>
     <p:sldId id="260" r:id="rId9"/>
-    <p:sldId id="261" r:id="rId10"/>
+    <p:sldId id="269" r:id="rId10"/>
     <p:sldId id="262" r:id="rId11"/>
     <p:sldId id="263" r:id="rId12"/>
     <p:sldId id="264" r:id="rId13"/>
-    <p:sldId id="265" r:id="rId14"/>
-    <p:sldId id="266" r:id="rId15"/>
-    <p:sldId id="268" r:id="rId16"/>
-    <p:sldId id="267" r:id="rId17"/>
+    <p:sldId id="270" r:id="rId14"/>
+    <p:sldId id="271" r:id="rId15"/>
+    <p:sldId id="272" r:id="rId16"/>
+    <p:sldId id="265" r:id="rId17"/>
+    <p:sldId id="266" r:id="rId18"/>
+    <p:sldId id="268" r:id="rId19"/>
+    <p:sldId id="267" r:id="rId20"/>
   </p:sldIdLst>
   <p:sldSz cx="9144000" cy="5143500" type="screen16x9"/>
   <p:notesSz cx="5143500" cy="9144000"/>
@@ -407,7 +410,7 @@
           <a:p>
             <a:fld id="{F7021451-1387-4CA6-816F-3879F97B5CBC}" type="slidenum">
               <a:rPr lang="en-US"/>
-              <a:t>10</a:t>
+              <a:t>13</a:t>
             </a:fld>
             <a:endParaRPr lang="en-US"/>
           </a:p>
@@ -491,7 +494,7 @@
           <a:p>
             <a:fld id="{F7021451-1387-4CA6-816F-3879F97B5CBC}" type="slidenum">
               <a:rPr lang="en-US"/>
-              <a:t>11</a:t>
+              <a:t>14</a:t>
             </a:fld>
             <a:endParaRPr lang="en-US"/>
           </a:p>
@@ -575,7 +578,7 @@
           <a:p>
             <a:fld id="{F7021451-1387-4CA6-816F-3879F97B5CBC}" type="slidenum">
               <a:rPr lang="en-US"/>
-              <a:t>12</a:t>
+              <a:t>15</a:t>
             </a:fld>
             <a:endParaRPr lang="en-US"/>
           </a:p>
@@ -659,7 +662,7 @@
           <a:p>
             <a:fld id="{F7021451-1387-4CA6-816F-3879F97B5CBC}" type="slidenum">
               <a:rPr lang="en-US"/>
-              <a:t>13</a:t>
+              <a:t>16</a:t>
             </a:fld>
             <a:endParaRPr lang="en-US"/>
           </a:p>
@@ -1770,7 +1773,7 @@
               <a:buNone/>
             </a:pPr>
             <a:r>
-              <a:rPr lang="en-US" sz="4400" b="1" kern="0" spc="200">
+              <a:rPr lang="en-US" sz="4400" b="1" kern="0" spc="200" dirty="0">
                 <a:solidFill>
                   <a:srgbClr val="FFFFFF"/>
                 </a:solidFill>
@@ -1780,7 +1783,7 @@
               </a:rPr>
               <a:t>CAPSTONE PROJECT</a:t>
             </a:r>
-            <a:endParaRPr lang="en-US" sz="4400"/>
+            <a:endParaRPr lang="en-US" sz="4400" dirty="0"/>
           </a:p>
         </p:txBody>
       </p:sp>
@@ -1847,14 +1850,13 @@
             <a:pPr marL="0" indent="0">
               <a:buNone/>
             </a:pPr>
-            <a:endParaRPr lang="en-US" sz="1400" dirty="0">
-              <a:latin typeface="Calibri"/>
-              <a:ea typeface="Calibri"/>
-              <a:cs typeface="Calibri"/>
-            </a:endParaRPr>
-            <a:r>
-              <a:rPr lang="en-US" dirty="0"/>
-              <a:t>Submission Template — Option 4</a:t>
+            <a:r>
+              <a:rPr lang="en-US" dirty="0">
+                <a:solidFill>
+                  <a:schemeClr val="bg1"/>
+                </a:solidFill>
+              </a:rPr>
+              <a:t>Submission Template - Option 4</a:t>
             </a:r>
           </a:p>
         </p:txBody>
@@ -1915,17 +1917,9 @@
           <a:lstStyle/>
           <a:p>
             <a:pPr algn="ctr"/>
-            <a:endParaRPr lang="en-US" sz="1400" dirty="0">
-              <a:solidFill>
-                <a:srgbClr val="025F62"/>
-              </a:solidFill>
-              <a:latin typeface="Calibri"/>
-              <a:ea typeface="Calibri"/>
-              <a:cs typeface="Calibri"/>
-            </a:endParaRPr>
             <a:r>
               <a:rPr lang="en-US" dirty="0"/>
-              <a:t>Option 4 — AI Case Study</a:t>
+              <a:t>Option 4 - AI Case Study</a:t>
             </a:r>
           </a:p>
         </p:txBody>
@@ -1994,13 +1988,12 @@
           <a:bodyPr wrap="square" lIns="91440" tIns="45720" rIns="91440" bIns="45720" rtlCol="0" anchor="ctr"/>
           <a:lstStyle/>
           <a:p>
-            <a:endParaRPr lang="en-US" sz="1300" dirty="0">
-              <a:latin typeface="Calibri"/>
-              <a:ea typeface="Calibri"/>
-              <a:cs typeface="Calibri"/>
-            </a:endParaRPr>
-            <a:r>
-              <a:rPr lang="en-US" dirty="0"/>
+            <a:r>
+              <a:rPr lang="en-US" dirty="0">
+                <a:solidFill>
+                  <a:schemeClr val="bg1"/>
+                </a:solidFill>
+              </a:rPr>
               <a:t>Name: Julian Largo Ramirez     Date: 2026-08-14</a:t>
             </a:r>
           </a:p>
@@ -2054,6 +2047,498 @@
 </file>
 
 <file path=ppt/slides/slide10.xml><?xml version="1.0" encoding="utf-8"?>
+<p:sld xmlns:a="http://schemas.openxmlformats.org/drawingml/2006/main" xmlns:r="http://schemas.openxmlformats.org/officeDocument/2006/relationships" xmlns:p="http://schemas.openxmlformats.org/presentationml/2006/main">
+  <p:cSld>
+    <p:spTree>
+      <p:nvGrpSpPr>
+        <p:cNvPr id="1" name=""/>
+        <p:cNvGrpSpPr/>
+        <p:nvPr/>
+      </p:nvGrpSpPr>
+      <p:grpSpPr>
+        <a:xfrm>
+          <a:off x="0" y="0"/>
+          <a:ext cx="0" cy="0"/>
+          <a:chOff x="0" y="0"/>
+          <a:chExt cx="0" cy="0"/>
+        </a:xfrm>
+      </p:grpSpPr>
+      <p:sp>
+        <p:nvSpPr>
+          <p:cNvPr id="3" name="Text 0">
+            <a:extLst>
+              <a:ext uri="{FF2B5EF4-FFF2-40B4-BE49-F238E27FC236}">
+                <a16:creationId xmlns:a16="http://schemas.microsoft.com/office/drawing/2014/main" id="{2321A389-EFBF-70BD-4069-5E47684E3A73}"/>
+              </a:ext>
+            </a:extLst>
+          </p:cNvPr>
+          <p:cNvSpPr/>
+          <p:nvPr/>
+        </p:nvSpPr>
+        <p:spPr>
+          <a:xfrm>
+            <a:off x="385200" y="79200"/>
+            <a:ext cx="7498080" cy="548640"/>
+          </a:xfrm>
+          <a:prstGeom prst="rect">
+            <a:avLst/>
+          </a:prstGeom>
+          <a:noFill/>
+          <a:ln/>
+        </p:spPr>
+        <p:txBody>
+          <a:bodyPr wrap="square" rtlCol="0" anchor="ctr"/>
+          <a:lstStyle/>
+          <a:p>
+            <a:pPr marL="0" indent="0" algn="ctr">
+              <a:buNone/>
+            </a:pPr>
+            <a:r>
+              <a:rPr lang="en-US" sz="2600" b="1" dirty="0">
+                <a:solidFill>
+                  <a:srgbClr val="024879"/>
+                </a:solidFill>
+                <a:latin typeface="Arial" pitchFamily="34" charset="0"/>
+                <a:ea typeface="Arial" pitchFamily="34" charset="-122"/>
+                <a:cs typeface="Arial" pitchFamily="34" charset="-120"/>
+              </a:rPr>
+              <a:t>Portkey usage</a:t>
+            </a:r>
+            <a:endParaRPr lang="en-US" sz="2600" dirty="0"/>
+          </a:p>
+        </p:txBody>
+      </p:sp>
+      <p:pic>
+        <p:nvPicPr>
+          <p:cNvPr id="5" name="Picture 4">
+            <a:extLst>
+              <a:ext uri="{FF2B5EF4-FFF2-40B4-BE49-F238E27FC236}">
+                <a16:creationId xmlns:a16="http://schemas.microsoft.com/office/drawing/2014/main" id="{E8255228-5BA7-BDE3-9055-C61A3D2DA97B}"/>
+              </a:ext>
+            </a:extLst>
+          </p:cNvPr>
+          <p:cNvPicPr>
+            <a:picLocks noChangeAspect="1"/>
+          </p:cNvPicPr>
+          <p:nvPr/>
+        </p:nvPicPr>
+        <p:blipFill>
+          <a:blip r:embed="rId2"/>
+          <a:stretch>
+            <a:fillRect/>
+          </a:stretch>
+        </p:blipFill>
+        <p:spPr>
+          <a:xfrm>
+            <a:off x="890084" y="704592"/>
+            <a:ext cx="7584316" cy="4359708"/>
+          </a:xfrm>
+          <a:prstGeom prst="rect">
+            <a:avLst/>
+          </a:prstGeom>
+        </p:spPr>
+      </p:pic>
+    </p:spTree>
+    <p:extLst>
+      <p:ext uri="{BB962C8B-B14F-4D97-AF65-F5344CB8AC3E}">
+        <p14:creationId xmlns:p14="http://schemas.microsoft.com/office/powerpoint/2010/main" val="2001062601"/>
+      </p:ext>
+    </p:extLst>
+  </p:cSld>
+  <p:clrMapOvr>
+    <a:masterClrMapping/>
+  </p:clrMapOvr>
+</p:sld>
+</file>
+
+<file path=ppt/slides/slide11.xml><?xml version="1.0" encoding="utf-8"?>
+<p:sld xmlns:a="http://schemas.openxmlformats.org/drawingml/2006/main" xmlns:r="http://schemas.openxmlformats.org/officeDocument/2006/relationships" xmlns:p="http://schemas.openxmlformats.org/presentationml/2006/main">
+  <p:cSld>
+    <p:spTree>
+      <p:nvGrpSpPr>
+        <p:cNvPr id="1" name="">
+          <a:extLst>
+            <a:ext uri="{FF2B5EF4-FFF2-40B4-BE49-F238E27FC236}">
+              <a16:creationId xmlns:a16="http://schemas.microsoft.com/office/drawing/2014/main" id="{889F6C54-64FD-5355-21B8-B9D9780BBE13}"/>
+            </a:ext>
+          </a:extLst>
+        </p:cNvPr>
+        <p:cNvGrpSpPr/>
+        <p:nvPr/>
+      </p:nvGrpSpPr>
+      <p:grpSpPr>
+        <a:xfrm>
+          <a:off x="0" y="0"/>
+          <a:ext cx="0" cy="0"/>
+          <a:chOff x="0" y="0"/>
+          <a:chExt cx="0" cy="0"/>
+        </a:xfrm>
+      </p:grpSpPr>
+      <p:sp>
+        <p:nvSpPr>
+          <p:cNvPr id="3" name="Text 0">
+            <a:extLst>
+              <a:ext uri="{FF2B5EF4-FFF2-40B4-BE49-F238E27FC236}">
+                <a16:creationId xmlns:a16="http://schemas.microsoft.com/office/drawing/2014/main" id="{21EE9B78-DE22-BE4B-D6A4-498903BE4748}"/>
+              </a:ext>
+            </a:extLst>
+          </p:cNvPr>
+          <p:cNvSpPr/>
+          <p:nvPr/>
+        </p:nvSpPr>
+        <p:spPr>
+          <a:xfrm>
+            <a:off x="385200" y="79200"/>
+            <a:ext cx="8622000" cy="548640"/>
+          </a:xfrm>
+          <a:prstGeom prst="rect">
+            <a:avLst/>
+          </a:prstGeom>
+          <a:noFill/>
+          <a:ln/>
+        </p:spPr>
+        <p:txBody>
+          <a:bodyPr wrap="square" rtlCol="0" anchor="ctr"/>
+          <a:lstStyle/>
+          <a:p>
+            <a:r>
+              <a:rPr lang="en-US" sz="2000" b="1" dirty="0">
+                <a:solidFill>
+                  <a:srgbClr val="024879"/>
+                </a:solidFill>
+                <a:latin typeface="Arial" pitchFamily="34" charset="0"/>
+                <a:cs typeface="Arial" pitchFamily="34" charset="-120"/>
+              </a:rPr>
+              <a:t>GitHub - </a:t>
+            </a:r>
+            <a:r>
+              <a:rPr lang="en-US" sz="1400" b="1" dirty="0">
+                <a:solidFill>
+                  <a:srgbClr val="024879"/>
+                </a:solidFill>
+                <a:latin typeface="Arial" pitchFamily="34" charset="0"/>
+                <a:cs typeface="Arial" pitchFamily="34" charset="-120"/>
+              </a:rPr>
+              <a:t>https://github.com/ajulian35/migration-cypress-to-playwright/tree/L2</a:t>
+            </a:r>
+            <a:r>
+              <a:rPr lang="en-US" b="1" dirty="0">
+                <a:solidFill>
+                  <a:srgbClr val="024879"/>
+                </a:solidFill>
+                <a:latin typeface="Arial" pitchFamily="34" charset="0"/>
+                <a:cs typeface="Arial" pitchFamily="34" charset="-120"/>
+              </a:rPr>
+              <a:t> </a:t>
+            </a:r>
+            <a:endParaRPr lang="en-US" sz="2600" dirty="0"/>
+          </a:p>
+        </p:txBody>
+      </p:sp>
+      <p:pic>
+        <p:nvPicPr>
+          <p:cNvPr id="4" name="Picture 3">
+            <a:extLst>
+              <a:ext uri="{FF2B5EF4-FFF2-40B4-BE49-F238E27FC236}">
+                <a16:creationId xmlns:a16="http://schemas.microsoft.com/office/drawing/2014/main" id="{E39E06B0-592F-9DA2-4DC7-669765A55271}"/>
+              </a:ext>
+            </a:extLst>
+          </p:cNvPr>
+          <p:cNvPicPr>
+            <a:picLocks noChangeAspect="1"/>
+          </p:cNvPicPr>
+          <p:nvPr/>
+        </p:nvPicPr>
+        <p:blipFill>
+          <a:blip r:embed="rId2"/>
+          <a:stretch>
+            <a:fillRect/>
+          </a:stretch>
+        </p:blipFill>
+        <p:spPr>
+          <a:xfrm>
+            <a:off x="44457" y="627840"/>
+            <a:ext cx="6093238" cy="4323430"/>
+          </a:xfrm>
+          <a:prstGeom prst="rect">
+            <a:avLst/>
+          </a:prstGeom>
+        </p:spPr>
+      </p:pic>
+      <p:pic>
+        <p:nvPicPr>
+          <p:cNvPr id="7" name="Picture 6">
+            <a:extLst>
+              <a:ext uri="{FF2B5EF4-FFF2-40B4-BE49-F238E27FC236}">
+                <a16:creationId xmlns:a16="http://schemas.microsoft.com/office/drawing/2014/main" id="{CF4ED5E6-CDBF-C685-CA56-101E146F5291}"/>
+              </a:ext>
+            </a:extLst>
+          </p:cNvPr>
+          <p:cNvPicPr>
+            <a:picLocks noChangeAspect="1"/>
+          </p:cNvPicPr>
+          <p:nvPr/>
+        </p:nvPicPr>
+        <p:blipFill>
+          <a:blip r:embed="rId3"/>
+          <a:stretch>
+            <a:fillRect/>
+          </a:stretch>
+        </p:blipFill>
+        <p:spPr>
+          <a:xfrm>
+            <a:off x="3441940" y="627840"/>
+            <a:ext cx="5657603" cy="4196948"/>
+          </a:xfrm>
+          <a:prstGeom prst="rect">
+            <a:avLst/>
+          </a:prstGeom>
+        </p:spPr>
+      </p:pic>
+    </p:spTree>
+    <p:extLst>
+      <p:ext uri="{BB962C8B-B14F-4D97-AF65-F5344CB8AC3E}">
+        <p14:creationId xmlns:p14="http://schemas.microsoft.com/office/powerpoint/2010/main" val="2324723644"/>
+      </p:ext>
+    </p:extLst>
+  </p:cSld>
+  <p:clrMapOvr>
+    <a:masterClrMapping/>
+  </p:clrMapOvr>
+</p:sld>
+</file>
+
+<file path=ppt/slides/slide12.xml><?xml version="1.0" encoding="utf-8"?>
+<p:sld xmlns:a="http://schemas.openxmlformats.org/drawingml/2006/main" xmlns:r="http://schemas.openxmlformats.org/officeDocument/2006/relationships" xmlns:p="http://schemas.openxmlformats.org/presentationml/2006/main">
+  <p:cSld>
+    <p:spTree>
+      <p:nvGrpSpPr>
+        <p:cNvPr id="1" name="">
+          <a:extLst>
+            <a:ext uri="{FF2B5EF4-FFF2-40B4-BE49-F238E27FC236}">
+              <a16:creationId xmlns:a16="http://schemas.microsoft.com/office/drawing/2014/main" id="{459C3D5F-5F94-3CB1-AF3D-DD4C95826B4A}"/>
+            </a:ext>
+          </a:extLst>
+        </p:cNvPr>
+        <p:cNvGrpSpPr/>
+        <p:nvPr/>
+      </p:nvGrpSpPr>
+      <p:grpSpPr>
+        <a:xfrm>
+          <a:off x="0" y="0"/>
+          <a:ext cx="0" cy="0"/>
+          <a:chOff x="0" y="0"/>
+          <a:chExt cx="0" cy="0"/>
+        </a:xfrm>
+      </p:grpSpPr>
+      <p:sp>
+        <p:nvSpPr>
+          <p:cNvPr id="3" name="Text 0">
+            <a:extLst>
+              <a:ext uri="{FF2B5EF4-FFF2-40B4-BE49-F238E27FC236}">
+                <a16:creationId xmlns:a16="http://schemas.microsoft.com/office/drawing/2014/main" id="{73D485B2-CD3B-3880-350F-6F74D7FEF306}"/>
+              </a:ext>
+            </a:extLst>
+          </p:cNvPr>
+          <p:cNvSpPr/>
+          <p:nvPr/>
+        </p:nvSpPr>
+        <p:spPr>
+          <a:xfrm>
+            <a:off x="385200" y="79200"/>
+            <a:ext cx="8622000" cy="548640"/>
+          </a:xfrm>
+          <a:prstGeom prst="rect">
+            <a:avLst/>
+          </a:prstGeom>
+          <a:noFill/>
+          <a:ln/>
+        </p:spPr>
+        <p:txBody>
+          <a:bodyPr wrap="square" rtlCol="0" anchor="ctr"/>
+          <a:lstStyle/>
+          <a:p>
+            <a:pPr algn="ctr"/>
+            <a:r>
+              <a:rPr lang="en-US" sz="2400" b="1" dirty="0">
+                <a:solidFill>
+                  <a:srgbClr val="024879"/>
+                </a:solidFill>
+                <a:latin typeface="Arial" pitchFamily="34" charset="0"/>
+                <a:cs typeface="Arial" pitchFamily="34" charset="-120"/>
+              </a:rPr>
+              <a:t>Results</a:t>
+            </a:r>
+            <a:r>
+              <a:rPr lang="en-US" sz="2000" b="1" dirty="0">
+                <a:solidFill>
+                  <a:srgbClr val="024879"/>
+                </a:solidFill>
+                <a:latin typeface="Arial" pitchFamily="34" charset="0"/>
+                <a:cs typeface="Arial" pitchFamily="34" charset="-120"/>
+              </a:rPr>
+              <a:t> </a:t>
+            </a:r>
+            <a:endParaRPr lang="en-US" sz="2600" dirty="0"/>
+          </a:p>
+        </p:txBody>
+      </p:sp>
+      <p:sp>
+        <p:nvSpPr>
+          <p:cNvPr id="5" name="Text 0">
+            <a:extLst>
+              <a:ext uri="{FF2B5EF4-FFF2-40B4-BE49-F238E27FC236}">
+                <a16:creationId xmlns:a16="http://schemas.microsoft.com/office/drawing/2014/main" id="{69CE0A46-6277-FB70-C834-615002EF349B}"/>
+              </a:ext>
+            </a:extLst>
+          </p:cNvPr>
+          <p:cNvSpPr/>
+          <p:nvPr/>
+        </p:nvSpPr>
+        <p:spPr>
+          <a:xfrm>
+            <a:off x="261000" y="1102800"/>
+            <a:ext cx="8622000" cy="548640"/>
+          </a:xfrm>
+          <a:prstGeom prst="rect">
+            <a:avLst/>
+          </a:prstGeom>
+          <a:noFill/>
+          <a:ln/>
+        </p:spPr>
+        <p:txBody>
+          <a:bodyPr wrap="square" rtlCol="0" anchor="ctr"/>
+          <a:lstStyle/>
+          <a:p>
+            <a:r>
+              <a:rPr lang="en-US" sz="2000" b="1" dirty="0">
+                <a:solidFill>
+                  <a:srgbClr val="024879"/>
+                </a:solidFill>
+                <a:latin typeface="Arial" pitchFamily="34" charset="0"/>
+                <a:cs typeface="Arial" pitchFamily="34" charset="-120"/>
+              </a:rPr>
+              <a:t>	     Cypress </a:t>
+            </a:r>
+            <a:endParaRPr lang="en-US" sz="2600" dirty="0"/>
+          </a:p>
+        </p:txBody>
+      </p:sp>
+      <p:sp>
+        <p:nvSpPr>
+          <p:cNvPr id="8" name="Text 0">
+            <a:extLst>
+              <a:ext uri="{FF2B5EF4-FFF2-40B4-BE49-F238E27FC236}">
+                <a16:creationId xmlns:a16="http://schemas.microsoft.com/office/drawing/2014/main" id="{4FD575A1-112D-5FCC-35C9-D368AE85E47C}"/>
+              </a:ext>
+            </a:extLst>
+          </p:cNvPr>
+          <p:cNvSpPr/>
+          <p:nvPr/>
+        </p:nvSpPr>
+        <p:spPr>
+          <a:xfrm>
+            <a:off x="5899800" y="1111200"/>
+            <a:ext cx="2720923" cy="548640"/>
+          </a:xfrm>
+          <a:prstGeom prst="rect">
+            <a:avLst/>
+          </a:prstGeom>
+          <a:noFill/>
+          <a:ln/>
+        </p:spPr>
+        <p:txBody>
+          <a:bodyPr wrap="square" rtlCol="0" anchor="ctr"/>
+          <a:lstStyle/>
+          <a:p>
+            <a:r>
+              <a:rPr lang="en-US" sz="2000" b="1" dirty="0">
+                <a:solidFill>
+                  <a:srgbClr val="024879"/>
+                </a:solidFill>
+                <a:latin typeface="Arial" pitchFamily="34" charset="0"/>
+                <a:cs typeface="Arial" pitchFamily="34" charset="-120"/>
+              </a:rPr>
+              <a:t>Playwright </a:t>
+            </a:r>
+            <a:endParaRPr lang="en-US" sz="2600" dirty="0"/>
+          </a:p>
+        </p:txBody>
+      </p:sp>
+      <p:pic>
+        <p:nvPicPr>
+          <p:cNvPr id="12" name="Picture 11">
+            <a:extLst>
+              <a:ext uri="{FF2B5EF4-FFF2-40B4-BE49-F238E27FC236}">
+                <a16:creationId xmlns:a16="http://schemas.microsoft.com/office/drawing/2014/main" id="{AF398236-A426-7297-811E-24D2F233B39E}"/>
+              </a:ext>
+            </a:extLst>
+          </p:cNvPr>
+          <p:cNvPicPr>
+            <a:picLocks noChangeAspect="1"/>
+          </p:cNvPicPr>
+          <p:nvPr/>
+        </p:nvPicPr>
+        <p:blipFill>
+          <a:blip r:embed="rId2"/>
+          <a:stretch>
+            <a:fillRect/>
+          </a:stretch>
+        </p:blipFill>
+        <p:spPr>
+          <a:xfrm>
+            <a:off x="86681" y="1815004"/>
+            <a:ext cx="4362919" cy="2785796"/>
+          </a:xfrm>
+          <a:prstGeom prst="rect">
+            <a:avLst/>
+          </a:prstGeom>
+        </p:spPr>
+      </p:pic>
+      <p:pic>
+        <p:nvPicPr>
+          <p:cNvPr id="14" name="Picture 13">
+            <a:extLst>
+              <a:ext uri="{FF2B5EF4-FFF2-40B4-BE49-F238E27FC236}">
+                <a16:creationId xmlns:a16="http://schemas.microsoft.com/office/drawing/2014/main" id="{825437CD-F68B-90F6-A19A-8B6972F2B258}"/>
+              </a:ext>
+            </a:extLst>
+          </p:cNvPr>
+          <p:cNvPicPr>
+            <a:picLocks noChangeAspect="1"/>
+          </p:cNvPicPr>
+          <p:nvPr/>
+        </p:nvPicPr>
+        <p:blipFill>
+          <a:blip r:embed="rId3"/>
+          <a:stretch>
+            <a:fillRect/>
+          </a:stretch>
+        </p:blipFill>
+        <p:spPr>
+          <a:xfrm>
+            <a:off x="4507200" y="1815004"/>
+            <a:ext cx="4572000" cy="2728196"/>
+          </a:xfrm>
+          <a:prstGeom prst="rect">
+            <a:avLst/>
+          </a:prstGeom>
+        </p:spPr>
+      </p:pic>
+    </p:spTree>
+    <p:extLst>
+      <p:ext uri="{BB962C8B-B14F-4D97-AF65-F5344CB8AC3E}">
+        <p14:creationId xmlns:p14="http://schemas.microsoft.com/office/powerpoint/2010/main" val="1429846213"/>
+      </p:ext>
+    </p:extLst>
+  </p:cSld>
+  <p:clrMapOvr>
+    <a:masterClrMapping/>
+  </p:clrMapOvr>
+</p:sld>
+</file>
+
+<file path=ppt/slides/slide13.xml><?xml version="1.0" encoding="utf-8"?>
 <p:sld xmlns:a="http://schemas.openxmlformats.org/drawingml/2006/main" xmlns:r="http://schemas.openxmlformats.org/officeDocument/2006/relationships" xmlns:p="http://schemas.openxmlformats.org/presentationml/2006/main">
   <p:cSld name="Slide 10">
     <p:bg>
@@ -3795,7 +4280,7 @@
 </p:sld>
 </file>
 
-<file path=ppt/slides/slide11.xml><?xml version="1.0" encoding="utf-8"?>
+<file path=ppt/slides/slide14.xml><?xml version="1.0" encoding="utf-8"?>
 <p:sld xmlns:a="http://schemas.openxmlformats.org/drawingml/2006/main" xmlns:r="http://schemas.openxmlformats.org/officeDocument/2006/relationships" xmlns:p="http://schemas.openxmlformats.org/presentationml/2006/main">
   <p:cSld name="Slide 11">
     <p:bg>
@@ -4053,7 +4538,6 @@
             <a:pPr marL="0" indent="0" algn="ctr">
               <a:buNone/>
             </a:pPr>
-            <a:endParaRPr lang="en-US" sz="1200"/>
             <a:r>
               <a:rPr lang="en-US" dirty="0"/>
               <a:t>22 / 30</a:t>
@@ -4192,7 +4676,6 @@
             <a:pPr marL="0" indent="0" algn="ctr">
               <a:buNone/>
             </a:pPr>
-            <a:endParaRPr lang="en-US" sz="1200"/>
             <a:r>
               <a:rPr lang="en-US" dirty="0"/>
               <a:t>26 / 30</a:t>
@@ -4331,7 +4814,6 @@
             <a:pPr marL="0" indent="0" algn="ctr">
               <a:buNone/>
             </a:pPr>
-            <a:endParaRPr lang="en-US" sz="1200"/>
             <a:r>
               <a:rPr lang="en-US" dirty="0"/>
               <a:t>24 / 30</a:t>
@@ -4470,7 +4952,6 @@
             <a:pPr marL="0" indent="0" algn="ctr">
               <a:buNone/>
             </a:pPr>
-            <a:endParaRPr lang="en-US" sz="1200"/>
             <a:r>
               <a:rPr lang="en-US" dirty="0"/>
               <a:t>24 / 30</a:t>
@@ -4609,7 +5090,6 @@
             <a:pPr marL="0" indent="0" algn="ctr">
               <a:buNone/>
             </a:pPr>
-            <a:endParaRPr lang="en-US" sz="1200"/>
             <a:r>
               <a:rPr lang="en-US" dirty="0"/>
               <a:t>18 / 30</a:t>
@@ -4670,9 +5150,12 @@
             <a:pPr marL="0" indent="0">
               <a:buNone/>
             </a:pPr>
-            <a:endParaRPr lang="en-US" sz="1600"/>
-            <a:r>
-              <a:rPr lang="en-US" dirty="0"/>
+            <a:r>
+              <a:rPr lang="en-US" dirty="0">
+                <a:solidFill>
+                  <a:schemeClr val="bg1"/>
+                </a:solidFill>
+              </a:rPr>
               <a:t>My total:  114 / 150      Clear = 70+     (I demonstrated 5 of 5 topics)</a:t>
             </a:r>
           </a:p>
@@ -4686,7 +5169,7 @@
 </p:sld>
 </file>
 
-<file path=ppt/slides/slide12.xml><?xml version="1.0" encoding="utf-8"?>
+<file path=ppt/slides/slide15.xml><?xml version="1.0" encoding="utf-8"?>
 <p:sld xmlns:a="http://schemas.openxmlformats.org/drawingml/2006/main" xmlns:r="http://schemas.openxmlformats.org/officeDocument/2006/relationships" xmlns:p="http://schemas.openxmlformats.org/presentationml/2006/main">
   <p:cSld name="Slide 13">
     <p:bg>
@@ -4868,21 +5351,20 @@
           <a:bodyPr wrap="square" rtlCol="0" anchor="ctr"/>
           <a:lstStyle/>
           <a:p>
-            <a:pPr marL="0" indent="0" algn="l">
-              <a:buNone/>
-            </a:pPr>
-            <a:r>
-              <a:rPr lang="en-US" sz="1100" i="1">
-                <a:solidFill>
-                  <a:srgbClr val="5A6B72"/>
-                </a:solidFill>
-                <a:latin typeface="Calibri" pitchFamily="34" charset="0"/>
-                <a:ea typeface="Calibri" pitchFamily="34" charset="-122"/>
-                <a:cs typeface="Calibri" pitchFamily="34" charset="-120"/>
-              </a:rPr>
-              <a:t>"Before this program, I thought AI was …"</a:t>
-            </a:r>
-            <a:endParaRPr lang="en-US" sz="1100"/>
+            <a:r>
+              <a:rPr lang="en-US" sz="1100" dirty="0">
+                <a:latin typeface="Arial" panose="020B0604020202020204" pitchFamily="34" charset="0"/>
+                <a:cs typeface="Arial" panose="020B0604020202020204" pitchFamily="34" charset="0"/>
+              </a:rPr>
+              <a:t>Before this program, I thought AI was a code autocomplete tool - useful for boilerplate but too unreliable for autonomous end-to-end workflows</a:t>
+            </a:r>
+            <a:r>
+              <a:rPr lang="en-US" sz="1200" dirty="0">
+                <a:latin typeface="Arial" panose="020B0604020202020204" pitchFamily="34" charset="0"/>
+                <a:cs typeface="Arial" panose="020B0604020202020204" pitchFamily="34" charset="0"/>
+              </a:rPr>
+              <a:t>.</a:t>
+            </a:r>
           </a:p>
         </p:txBody>
       </p:sp>
@@ -4895,7 +5377,7 @@
         <p:spPr>
           <a:xfrm>
             <a:off x="457200" y="1920240"/>
-            <a:ext cx="8229600" cy="457200"/>
+            <a:ext cx="8229600" cy="576072"/>
           </a:xfrm>
           <a:prstGeom prst="roundRect">
             <a:avLst>
@@ -4944,11 +5426,7 @@
             <a:pPr marL="0" indent="0" algn="l">
               <a:buNone/>
             </a:pPr>
-            <a:endParaRPr lang="en-US" sz="1100"/>
-            <a:r>
-              <a:rPr lang="en-US" dirty="0"/>
-              <a:t>"Before this program, I thought AI was a code autocomplete tool — useful for boilerplate but too unreliable for autonomous end-to-end workflows."</a:t>
-            </a:r>
+            <a:endParaRPr lang="en-US" dirty="0"/>
           </a:p>
         </p:txBody>
       </p:sp>
@@ -5049,10 +5527,12 @@
             <a:pPr marL="0" indent="0" algn="l">
               <a:buNone/>
             </a:pPr>
-            <a:endParaRPr lang="en-US" sz="1100"/>
-            <a:r>
-              <a:rPr lang="en-US" dirty="0"/>
-              <a:t>The most valuable skill is not prompting — it is designing the failure handling path. An agent that validates its own tool output and retries with the failure reason embedded is fundamentally different from one that trusts every response. That difference is where production readiness lives.</a:t>
+            <a:r>
+              <a:rPr lang="en-US" sz="1200" dirty="0">
+                <a:latin typeface="Arial" panose="020B0604020202020204" pitchFamily="34" charset="0"/>
+                <a:cs typeface="Arial" panose="020B0604020202020204" pitchFamily="34" charset="0"/>
+              </a:rPr>
+              <a:t>The most valuable skill is not prompting - it is designing the failure handling path. An agent that validates its own tool output and retries with the failure reason embedded is fundamentally different from one that trusts every response.</a:t>
             </a:r>
           </a:p>
         </p:txBody>
@@ -5120,10 +5600,9 @@
             <a:pPr marL="0" indent="0">
               <a:buNone/>
             </a:pPr>
-            <a:endParaRPr lang="en-US" sz="1300"/>
             <a:r>
               <a:rPr lang="en-US" dirty="0"/>
-              <a:t>Before: 4 / 10        After: 8 / 10</a:t>
+              <a:t>Before: 2 / 10        After: 8 / 10</a:t>
             </a:r>
           </a:p>
         </p:txBody>
@@ -5176,7 +5655,7 @@
         <p:spPr>
           <a:xfrm>
             <a:off x="4709160" y="3794760"/>
-            <a:ext cx="3977640" cy="457200"/>
+            <a:ext cx="3977640" cy="705240"/>
           </a:xfrm>
           <a:prstGeom prst="roundRect">
             <a:avLst>
@@ -5197,7 +5676,366 @@
           <a:bodyPr/>
           <a:lstStyle/>
           <a:p>
-            <a:endParaRPr lang="en-US"/>
+            <a:r>
+              <a:rPr lang="es-CO" sz="1100" i="1" dirty="0" err="1">
+                <a:solidFill>
+                  <a:srgbClr val="5A6B72"/>
+                </a:solidFill>
+                <a:latin typeface="Arial" panose="020B0604020202020204" pitchFamily="34" charset="0"/>
+                <a:ea typeface="Calibri" pitchFamily="34" charset="-122"/>
+                <a:cs typeface="Arial" panose="020B0604020202020204" pitchFamily="34" charset="0"/>
+              </a:rPr>
+              <a:t>We</a:t>
+            </a:r>
+            <a:r>
+              <a:rPr lang="es-CO" sz="1100" i="1" dirty="0">
+                <a:solidFill>
+                  <a:srgbClr val="5A6B72"/>
+                </a:solidFill>
+                <a:latin typeface="Arial" panose="020B0604020202020204" pitchFamily="34" charset="0"/>
+                <a:ea typeface="Calibri" pitchFamily="34" charset="-122"/>
+                <a:cs typeface="Arial" panose="020B0604020202020204" pitchFamily="34" charset="0"/>
+              </a:rPr>
+              <a:t> </a:t>
+            </a:r>
+            <a:r>
+              <a:rPr lang="es-CO" sz="1100" i="1" dirty="0" err="1">
+                <a:solidFill>
+                  <a:srgbClr val="5A6B72"/>
+                </a:solidFill>
+                <a:latin typeface="Arial" panose="020B0604020202020204" pitchFamily="34" charset="0"/>
+                <a:ea typeface="Calibri" pitchFamily="34" charset="-122"/>
+                <a:cs typeface="Arial" panose="020B0604020202020204" pitchFamily="34" charset="0"/>
+              </a:rPr>
+              <a:t>should</a:t>
+            </a:r>
+            <a:r>
+              <a:rPr lang="es-CO" sz="1100" i="1" dirty="0">
+                <a:solidFill>
+                  <a:srgbClr val="5A6B72"/>
+                </a:solidFill>
+                <a:latin typeface="Arial" panose="020B0604020202020204" pitchFamily="34" charset="0"/>
+                <a:ea typeface="Calibri" pitchFamily="34" charset="-122"/>
+                <a:cs typeface="Arial" panose="020B0604020202020204" pitchFamily="34" charset="0"/>
+              </a:rPr>
+              <a:t> </a:t>
+            </a:r>
+            <a:r>
+              <a:rPr lang="es-CO" sz="1100" i="1" dirty="0" err="1">
+                <a:solidFill>
+                  <a:srgbClr val="5A6B72"/>
+                </a:solidFill>
+                <a:latin typeface="Arial" panose="020B0604020202020204" pitchFamily="34" charset="0"/>
+                <a:ea typeface="Calibri" pitchFamily="34" charset="-122"/>
+                <a:cs typeface="Arial" panose="020B0604020202020204" pitchFamily="34" charset="0"/>
+              </a:rPr>
+              <a:t>provide</a:t>
+            </a:r>
+            <a:r>
+              <a:rPr lang="es-CO" sz="1100" i="1" dirty="0">
+                <a:solidFill>
+                  <a:srgbClr val="5A6B72"/>
+                </a:solidFill>
+                <a:latin typeface="Arial" panose="020B0604020202020204" pitchFamily="34" charset="0"/>
+                <a:ea typeface="Calibri" pitchFamily="34" charset="-122"/>
+                <a:cs typeface="Arial" panose="020B0604020202020204" pitchFamily="34" charset="0"/>
+              </a:rPr>
+              <a:t> </a:t>
+            </a:r>
+            <a:r>
+              <a:rPr lang="es-CO" sz="1100" i="1" dirty="0" err="1">
+                <a:solidFill>
+                  <a:srgbClr val="5A6B72"/>
+                </a:solidFill>
+                <a:latin typeface="Arial" panose="020B0604020202020204" pitchFamily="34" charset="0"/>
+                <a:ea typeface="Calibri" pitchFamily="34" charset="-122"/>
+                <a:cs typeface="Arial" panose="020B0604020202020204" pitchFamily="34" charset="0"/>
+              </a:rPr>
+              <a:t>greater</a:t>
+            </a:r>
+            <a:r>
+              <a:rPr lang="es-CO" sz="1100" i="1" dirty="0">
+                <a:solidFill>
+                  <a:srgbClr val="5A6B72"/>
+                </a:solidFill>
+                <a:latin typeface="Arial" panose="020B0604020202020204" pitchFamily="34" charset="0"/>
+                <a:ea typeface="Calibri" pitchFamily="34" charset="-122"/>
+                <a:cs typeface="Arial" panose="020B0604020202020204" pitchFamily="34" charset="0"/>
+              </a:rPr>
+              <a:t> </a:t>
+            </a:r>
+            <a:r>
+              <a:rPr lang="es-CO" sz="1100" i="1" dirty="0" err="1">
+                <a:solidFill>
+                  <a:srgbClr val="5A6B72"/>
+                </a:solidFill>
+                <a:latin typeface="Arial" panose="020B0604020202020204" pitchFamily="34" charset="0"/>
+                <a:ea typeface="Calibri" pitchFamily="34" charset="-122"/>
+                <a:cs typeface="Arial" panose="020B0604020202020204" pitchFamily="34" charset="0"/>
+              </a:rPr>
+              <a:t>support</a:t>
+            </a:r>
+            <a:r>
+              <a:rPr lang="es-CO" sz="1100" i="1" dirty="0">
+                <a:solidFill>
+                  <a:srgbClr val="5A6B72"/>
+                </a:solidFill>
+                <a:latin typeface="Arial" panose="020B0604020202020204" pitchFamily="34" charset="0"/>
+                <a:ea typeface="Calibri" pitchFamily="34" charset="-122"/>
+                <a:cs typeface="Arial" panose="020B0604020202020204" pitchFamily="34" charset="0"/>
+              </a:rPr>
+              <a:t> </a:t>
+            </a:r>
+            <a:r>
+              <a:rPr lang="es-CO" sz="1100" i="1" dirty="0" err="1">
+                <a:solidFill>
+                  <a:srgbClr val="5A6B72"/>
+                </a:solidFill>
+                <a:latin typeface="Arial" panose="020B0604020202020204" pitchFamily="34" charset="0"/>
+                <a:ea typeface="Calibri" pitchFamily="34" charset="-122"/>
+                <a:cs typeface="Arial" panose="020B0604020202020204" pitchFamily="34" charset="0"/>
+              </a:rPr>
+              <a:t>for</a:t>
+            </a:r>
+            <a:r>
+              <a:rPr lang="es-CO" sz="1100" i="1" dirty="0">
+                <a:solidFill>
+                  <a:srgbClr val="5A6B72"/>
+                </a:solidFill>
+                <a:latin typeface="Arial" panose="020B0604020202020204" pitchFamily="34" charset="0"/>
+                <a:ea typeface="Calibri" pitchFamily="34" charset="-122"/>
+                <a:cs typeface="Arial" panose="020B0604020202020204" pitchFamily="34" charset="0"/>
+              </a:rPr>
+              <a:t> </a:t>
+            </a:r>
+            <a:r>
+              <a:rPr lang="es-CO" sz="1100" i="1" dirty="0" err="1">
+                <a:solidFill>
+                  <a:srgbClr val="5A6B72"/>
+                </a:solidFill>
+                <a:latin typeface="Arial" panose="020B0604020202020204" pitchFamily="34" charset="0"/>
+                <a:ea typeface="Calibri" pitchFamily="34" charset="-122"/>
+                <a:cs typeface="Arial" panose="020B0604020202020204" pitchFamily="34" charset="0"/>
+              </a:rPr>
+              <a:t>nontechnical</a:t>
+            </a:r>
+            <a:r>
+              <a:rPr lang="es-CO" sz="1100" i="1" dirty="0">
+                <a:solidFill>
+                  <a:srgbClr val="5A6B72"/>
+                </a:solidFill>
+                <a:latin typeface="Arial" panose="020B0604020202020204" pitchFamily="34" charset="0"/>
+                <a:ea typeface="Calibri" pitchFamily="34" charset="-122"/>
+                <a:cs typeface="Arial" panose="020B0604020202020204" pitchFamily="34" charset="0"/>
+              </a:rPr>
+              <a:t> </a:t>
+            </a:r>
+            <a:r>
+              <a:rPr lang="es-CO" sz="1100" i="1" dirty="0" err="1">
+                <a:solidFill>
+                  <a:srgbClr val="5A6B72"/>
+                </a:solidFill>
+                <a:latin typeface="Arial" panose="020B0604020202020204" pitchFamily="34" charset="0"/>
+                <a:ea typeface="Calibri" pitchFamily="34" charset="-122"/>
+                <a:cs typeface="Arial" panose="020B0604020202020204" pitchFamily="34" charset="0"/>
+              </a:rPr>
+              <a:t>individuals</a:t>
+            </a:r>
+            <a:r>
+              <a:rPr lang="es-CO" sz="1100" i="1" dirty="0">
+                <a:solidFill>
+                  <a:srgbClr val="5A6B72"/>
+                </a:solidFill>
+                <a:latin typeface="Arial" panose="020B0604020202020204" pitchFamily="34" charset="0"/>
+                <a:ea typeface="Calibri" pitchFamily="34" charset="-122"/>
+                <a:cs typeface="Arial" panose="020B0604020202020204" pitchFamily="34" charset="0"/>
+              </a:rPr>
+              <a:t> and Spanish </a:t>
+            </a:r>
+            <a:r>
+              <a:rPr lang="es-CO" sz="1100" i="1" dirty="0" err="1">
+                <a:solidFill>
+                  <a:srgbClr val="5A6B72"/>
+                </a:solidFill>
+                <a:latin typeface="Arial" panose="020B0604020202020204" pitchFamily="34" charset="0"/>
+                <a:ea typeface="Calibri" pitchFamily="34" charset="-122"/>
+                <a:cs typeface="Arial" panose="020B0604020202020204" pitchFamily="34" charset="0"/>
+              </a:rPr>
+              <a:t>speakers</a:t>
+            </a:r>
+            <a:r>
+              <a:rPr lang="es-CO" sz="1100" i="1" dirty="0">
+                <a:solidFill>
+                  <a:srgbClr val="5A6B72"/>
+                </a:solidFill>
+                <a:latin typeface="Arial" panose="020B0604020202020204" pitchFamily="34" charset="0"/>
+                <a:ea typeface="Calibri" pitchFamily="34" charset="-122"/>
+                <a:cs typeface="Arial" panose="020B0604020202020204" pitchFamily="34" charset="0"/>
+              </a:rPr>
+              <a:t> </a:t>
+            </a:r>
+            <a:r>
+              <a:rPr lang="es-CO" sz="1100" i="1" dirty="0" err="1">
+                <a:solidFill>
+                  <a:srgbClr val="5A6B72"/>
+                </a:solidFill>
+                <a:latin typeface="Arial" panose="020B0604020202020204" pitchFamily="34" charset="0"/>
+                <a:ea typeface="Calibri" pitchFamily="34" charset="-122"/>
+                <a:cs typeface="Arial" panose="020B0604020202020204" pitchFamily="34" charset="0"/>
+              </a:rPr>
+              <a:t>throughout</a:t>
+            </a:r>
+            <a:r>
+              <a:rPr lang="es-CO" sz="1100" i="1" dirty="0">
+                <a:solidFill>
+                  <a:srgbClr val="5A6B72"/>
+                </a:solidFill>
+                <a:latin typeface="Arial" panose="020B0604020202020204" pitchFamily="34" charset="0"/>
+                <a:ea typeface="Calibri" pitchFamily="34" charset="-122"/>
+                <a:cs typeface="Arial" panose="020B0604020202020204" pitchFamily="34" charset="0"/>
+              </a:rPr>
+              <a:t> </a:t>
+            </a:r>
+            <a:r>
+              <a:rPr lang="es-CO" sz="1100" i="1" dirty="0" err="1">
+                <a:solidFill>
+                  <a:srgbClr val="5A6B72"/>
+                </a:solidFill>
+                <a:latin typeface="Arial" panose="020B0604020202020204" pitchFamily="34" charset="0"/>
+                <a:ea typeface="Calibri" pitchFamily="34" charset="-122"/>
+                <a:cs typeface="Arial" panose="020B0604020202020204" pitchFamily="34" charset="0"/>
+              </a:rPr>
+              <a:t>the</a:t>
+            </a:r>
+            <a:r>
+              <a:rPr lang="es-CO" sz="1100" i="1" dirty="0">
+                <a:solidFill>
+                  <a:srgbClr val="5A6B72"/>
+                </a:solidFill>
+                <a:latin typeface="Arial" panose="020B0604020202020204" pitchFamily="34" charset="0"/>
+                <a:ea typeface="Calibri" pitchFamily="34" charset="-122"/>
+                <a:cs typeface="Arial" panose="020B0604020202020204" pitchFamily="34" charset="0"/>
+              </a:rPr>
+              <a:t> </a:t>
+            </a:r>
+            <a:r>
+              <a:rPr lang="es-CO" sz="1100" i="1" dirty="0" err="1">
+                <a:solidFill>
+                  <a:srgbClr val="5A6B72"/>
+                </a:solidFill>
+                <a:latin typeface="Arial" panose="020B0604020202020204" pitchFamily="34" charset="0"/>
+                <a:ea typeface="Calibri" pitchFamily="34" charset="-122"/>
+                <a:cs typeface="Arial" panose="020B0604020202020204" pitchFamily="34" charset="0"/>
+              </a:rPr>
+              <a:t>development</a:t>
+            </a:r>
+            <a:r>
+              <a:rPr lang="es-CO" sz="1100" i="1" dirty="0">
+                <a:solidFill>
+                  <a:srgbClr val="5A6B72"/>
+                </a:solidFill>
+                <a:latin typeface="Arial" panose="020B0604020202020204" pitchFamily="34" charset="0"/>
+                <a:ea typeface="Calibri" pitchFamily="34" charset="-122"/>
+                <a:cs typeface="Arial" panose="020B0604020202020204" pitchFamily="34" charset="0"/>
+              </a:rPr>
+              <a:t> </a:t>
+            </a:r>
+            <a:r>
+              <a:rPr lang="es-CO" sz="1100" i="1" dirty="0" err="1">
+                <a:solidFill>
+                  <a:srgbClr val="5A6B72"/>
+                </a:solidFill>
+                <a:latin typeface="Arial" panose="020B0604020202020204" pitchFamily="34" charset="0"/>
+                <a:ea typeface="Calibri" pitchFamily="34" charset="-122"/>
+                <a:cs typeface="Arial" panose="020B0604020202020204" pitchFamily="34" charset="0"/>
+              </a:rPr>
+              <a:t>of</a:t>
+            </a:r>
+            <a:r>
+              <a:rPr lang="es-CO" sz="1100" i="1" dirty="0">
+                <a:solidFill>
+                  <a:srgbClr val="5A6B72"/>
+                </a:solidFill>
+                <a:latin typeface="Arial" panose="020B0604020202020204" pitchFamily="34" charset="0"/>
+                <a:ea typeface="Calibri" pitchFamily="34" charset="-122"/>
+                <a:cs typeface="Arial" panose="020B0604020202020204" pitchFamily="34" charset="0"/>
+              </a:rPr>
+              <a:t> </a:t>
+            </a:r>
+            <a:r>
+              <a:rPr lang="es-CO" sz="1100" i="1" dirty="0" err="1">
+                <a:solidFill>
+                  <a:srgbClr val="5A6B72"/>
+                </a:solidFill>
+                <a:latin typeface="Arial" panose="020B0604020202020204" pitchFamily="34" charset="0"/>
+                <a:ea typeface="Calibri" pitchFamily="34" charset="-122"/>
+                <a:cs typeface="Arial" panose="020B0604020202020204" pitchFamily="34" charset="0"/>
+              </a:rPr>
+              <a:t>their</a:t>
+            </a:r>
+            <a:r>
+              <a:rPr lang="es-CO" sz="1100" i="1" dirty="0">
+                <a:solidFill>
+                  <a:srgbClr val="5A6B72"/>
+                </a:solidFill>
+                <a:latin typeface="Arial" panose="020B0604020202020204" pitchFamily="34" charset="0"/>
+                <a:ea typeface="Calibri" pitchFamily="34" charset="-122"/>
+                <a:cs typeface="Arial" panose="020B0604020202020204" pitchFamily="34" charset="0"/>
+              </a:rPr>
+              <a:t> </a:t>
+            </a:r>
+            <a:r>
+              <a:rPr lang="es-CO" sz="1100" i="1" dirty="0" err="1">
+                <a:solidFill>
+                  <a:srgbClr val="5A6B72"/>
+                </a:solidFill>
+                <a:latin typeface="Arial" panose="020B0604020202020204" pitchFamily="34" charset="0"/>
+                <a:ea typeface="Calibri" pitchFamily="34" charset="-122"/>
+                <a:cs typeface="Arial" panose="020B0604020202020204" pitchFamily="34" charset="0"/>
+              </a:rPr>
+              <a:t>capstone</a:t>
+            </a:r>
+            <a:r>
+              <a:rPr lang="es-CO" sz="1100" i="1" dirty="0">
+                <a:solidFill>
+                  <a:srgbClr val="5A6B72"/>
+                </a:solidFill>
+                <a:latin typeface="Arial" panose="020B0604020202020204" pitchFamily="34" charset="0"/>
+                <a:ea typeface="Calibri" pitchFamily="34" charset="-122"/>
+                <a:cs typeface="Arial" panose="020B0604020202020204" pitchFamily="34" charset="0"/>
+              </a:rPr>
+              <a:t> </a:t>
+            </a:r>
+            <a:r>
+              <a:rPr lang="es-CO" sz="1100" i="1" dirty="0" err="1">
+                <a:solidFill>
+                  <a:srgbClr val="5A6B72"/>
+                </a:solidFill>
+                <a:latin typeface="Arial" panose="020B0604020202020204" pitchFamily="34" charset="0"/>
+                <a:ea typeface="Calibri" pitchFamily="34" charset="-122"/>
+                <a:cs typeface="Arial" panose="020B0604020202020204" pitchFamily="34" charset="0"/>
+              </a:rPr>
+              <a:t>projects</a:t>
+            </a:r>
+            <a:r>
+              <a:rPr lang="es-CO" sz="1100" i="1" dirty="0">
+                <a:solidFill>
+                  <a:srgbClr val="5A6B72"/>
+                </a:solidFill>
+                <a:latin typeface="Arial" panose="020B0604020202020204" pitchFamily="34" charset="0"/>
+                <a:ea typeface="Calibri" pitchFamily="34" charset="-122"/>
+                <a:cs typeface="Arial" panose="020B0604020202020204" pitchFamily="34" charset="0"/>
+              </a:rPr>
+              <a:t>.</a:t>
+            </a:r>
+            <a:endParaRPr lang="en-US" sz="1100" i="1" dirty="0">
+              <a:solidFill>
+                <a:srgbClr val="5A6B72"/>
+              </a:solidFill>
+              <a:latin typeface="Arial" panose="020B0604020202020204" pitchFamily="34" charset="0"/>
+              <a:ea typeface="Calibri" pitchFamily="34" charset="-122"/>
+              <a:cs typeface="Arial" panose="020B0604020202020204" pitchFamily="34" charset="0"/>
+            </a:endParaRPr>
           </a:p>
         </p:txBody>
       </p:sp>
@@ -5209,8 +6047,8 @@
         </p:nvSpPr>
         <p:spPr>
           <a:xfrm>
-            <a:off x="4818888" y="3794760"/>
-            <a:ext cx="3758184" cy="457200"/>
+            <a:off x="566928" y="1940544"/>
+            <a:ext cx="8010144" cy="521208"/>
           </a:xfrm>
           <a:prstGeom prst="rect">
             <a:avLst/>
@@ -5222,14 +6060,21 @@
           <a:bodyPr wrap="square" rtlCol="0" anchor="ctr"/>
           <a:lstStyle/>
           <a:p>
-            <a:pPr marL="0" indent="0" algn="l">
-              <a:buNone/>
-            </a:pPr>
-            <a:endParaRPr lang="en-US" sz="1100"/>
-            <a:r>
-              <a:rPr lang="en-US" dirty="0"/>
-              <a:t>Give the agent a live DOM to work with (MCP Playwright), not just a static spec. The gap between what the spec says and what the running app actually renders is where most bugs hide — and only a live-browser agent can close that gap.</a:t>
-            </a:r>
+            <a:r>
+              <a:rPr lang="en-US" sz="1100" i="1" dirty="0">
+                <a:solidFill>
+                  <a:srgbClr val="5A6B72"/>
+                </a:solidFill>
+                <a:latin typeface="Arial" panose="020B0604020202020204" pitchFamily="34" charset="0"/>
+                <a:ea typeface="Calibri" pitchFamily="34" charset="-122"/>
+                <a:cs typeface="Arial" panose="020B0604020202020204" pitchFamily="34" charset="0"/>
+              </a:rPr>
+              <a:t>Now I see AI as a force multiplier for repetitive, well-defined tasks. However, it can generate code that appears correct at first glance but fails in edge cases that were not encountered during the agent's exploration. That is why tester review remains essential.</a:t>
+            </a:r>
+            <a:endParaRPr lang="en-US" sz="1100" dirty="0">
+              <a:latin typeface="Arial" panose="020B0604020202020204" pitchFamily="34" charset="0"/>
+              <a:cs typeface="Arial" panose="020B0604020202020204" pitchFamily="34" charset="0"/>
+            </a:endParaRPr>
           </a:p>
         </p:txBody>
       </p:sp>
@@ -5280,7 +6125,7 @@
 </p:sld>
 </file>
 
-<file path=ppt/slides/slide13.xml><?xml version="1.0" encoding="utf-8"?>
+<file path=ppt/slides/slide16.xml><?xml version="1.0" encoding="utf-8"?>
 <p:sld xmlns:a="http://schemas.openxmlformats.org/drawingml/2006/main" xmlns:r="http://schemas.openxmlformats.org/officeDocument/2006/relationships" xmlns:p="http://schemas.openxmlformats.org/presentationml/2006/main">
   <p:cSld name="Slide 12">
     <p:bg>
@@ -7108,7 +7953,7 @@
         </p:nvSpPr>
         <p:spPr>
           <a:xfrm>
-            <a:off x="457200" y="1097280"/>
+            <a:off x="548640" y="1106424"/>
             <a:ext cx="3977640" cy="457200"/>
           </a:xfrm>
           <a:prstGeom prst="roundRect">
@@ -7125,7 +7970,21 @@
           <a:bodyPr/>
           <a:lstStyle/>
           <a:p>
-            <a:endParaRPr lang="en-US"/>
+            <a:r>
+              <a:rPr lang="en-US" sz="1400" b="1" dirty="0">
+                <a:solidFill>
+                  <a:srgbClr val="FFFFFF"/>
+                </a:solidFill>
+                <a:latin typeface="Arial" pitchFamily="34" charset="0"/>
+                <a:ea typeface="Arial" pitchFamily="34" charset="-122"/>
+                <a:cs typeface="Arial" pitchFamily="34" charset="-120"/>
+              </a:rPr>
+              <a:t>OPTION 1 — Customer Project</a:t>
+            </a:r>
+            <a:endParaRPr lang="en-US" sz="1400" dirty="0"/>
+          </a:p>
+          <a:p>
+            <a:endParaRPr lang="en-US" dirty="0"/>
           </a:p>
         </p:txBody>
       </p:sp>
@@ -7154,10 +8013,6 @@
               <a:buNone/>
             </a:pPr>
             <a:endParaRPr lang="en-US" sz="1300"/>
-            <a:r>
-              <a:rPr lang="en-US" dirty="0"/>
-              <a:t>OPTION 4 — AI Case Study</a:t>
-            </a:r>
           </a:p>
         </p:txBody>
       </p:sp>
@@ -7186,10 +8041,6 @@
               <a:buNone/>
             </a:pPr>
             <a:endParaRPr lang="en-US" sz="1200"/>
-            <a:r>
-              <a:rPr lang="en-US" dirty="0"/>
-              <a:t>Domain &amp; engagement</a:t>
-            </a:r>
           </a:p>
         </p:txBody>
       </p:sp>
@@ -7201,8 +8052,8 @@
         </p:nvSpPr>
         <p:spPr>
           <a:xfrm>
-            <a:off x="457200" y="1947672"/>
-            <a:ext cx="3977640" cy="457200"/>
+            <a:off x="521208" y="1627632"/>
+            <a:ext cx="3977640" cy="941832"/>
           </a:xfrm>
           <a:prstGeom prst="roundRect">
             <a:avLst>
@@ -7235,7 +8086,7 @@
         </p:nvSpPr>
         <p:spPr>
           <a:xfrm>
-            <a:off x="566928" y="1947672"/>
+            <a:off x="566928" y="1852704"/>
             <a:ext cx="3758184" cy="457200"/>
           </a:xfrm>
           <a:prstGeom prst="rect">
@@ -7251,19 +8102,23 @@
             <a:pPr marL="0" indent="0" algn="l">
               <a:buNone/>
             </a:pPr>
-            <a:endParaRPr lang="en-US" sz="1100"/>
-            <a:r>
-              <a:rPr lang="en-US" dirty="0"/>
-              <a:t>QA Engineering — Cypress to Playwright Migration</a:t>
+            <a:r>
+              <a:rPr lang="en-US" sz="1200" dirty="0">
+                <a:latin typeface="Arial" panose="020B0604020202020204" pitchFamily="34" charset="0"/>
+                <a:cs typeface="Arial" panose="020B0604020202020204" pitchFamily="34" charset="0"/>
+              </a:rPr>
+              <a:t>QA Engineering - Cypress to Playwright Migration</a:t>
             </a:r>
           </a:p>
           <a:p>
             <a:pPr marL="0" indent="0" algn="l">
               <a:buNone/>
             </a:pPr>
-            <a:endParaRPr lang="en-US" sz="1100"/>
-            <a:r>
-              <a:rPr lang="en-US" dirty="0"/>
+            <a:r>
+              <a:rPr lang="en-US" sz="1200" dirty="0">
+                <a:latin typeface="Arial" panose="020B0604020202020204" pitchFamily="34" charset="0"/>
+                <a:cs typeface="Arial" panose="020B0604020202020204" pitchFamily="34" charset="0"/>
+              </a:rPr>
               <a:t>Perficient AI Capstone L2 (internal, OrangeHRM public demo)</a:t>
             </a:r>
           </a:p>
@@ -7294,10 +8149,6 @@
               <a:buNone/>
             </a:pPr>
             <a:endParaRPr lang="en-US" sz="1200"/>
-            <a:r>
-              <a:rPr lang="en-US" dirty="0"/>
-              <a:t>Problem · AI solution · outcomes</a:t>
-            </a:r>
           </a:p>
         </p:txBody>
       </p:sp>
@@ -7309,8 +8160,8 @@
         </p:nvSpPr>
         <p:spPr>
           <a:xfrm>
-            <a:off x="457200" y="2788920"/>
-            <a:ext cx="3977640" cy="457200"/>
+            <a:off x="502920" y="2718648"/>
+            <a:ext cx="3977640" cy="941832"/>
           </a:xfrm>
           <a:prstGeom prst="roundRect">
             <a:avLst>
@@ -7343,7 +8194,7 @@
         </p:nvSpPr>
         <p:spPr>
           <a:xfrm>
-            <a:off x="566928" y="2788920"/>
+            <a:off x="612648" y="2938284"/>
             <a:ext cx="3758184" cy="457200"/>
           </a:xfrm>
           <a:prstGeom prst="rect">
@@ -7359,9 +8210,11 @@
             <a:pPr marL="0" indent="0" algn="l">
               <a:buNone/>
             </a:pPr>
-            <a:endParaRPr lang="en-US" sz="1100"/>
-            <a:r>
-              <a:rPr lang="en-US" dirty="0"/>
+            <a:r>
+              <a:rPr lang="en-US" sz="1200" dirty="0">
+                <a:latin typeface="Arial" panose="020B0604020202020204" pitchFamily="34" charset="0"/>
+                <a:cs typeface="Arial" panose="020B0604020202020204" pitchFamily="34" charset="0"/>
+              </a:rPr>
               <a:t>7 Cypress TypeScript E2E tests migrated to Playwright Python BDD.</a:t>
             </a:r>
           </a:p>
@@ -7369,53 +8222,41 @@
             <a:pPr marL="0" indent="0" algn="l">
               <a:buNone/>
             </a:pPr>
-            <a:endParaRPr lang="en-US" sz="1100"/>
-            <a:r>
-              <a:rPr lang="en-US" dirty="0"/>
-              <a:t>Claude Code agent with MCP Playwright navigated the live app,</a:t>
-            </a:r>
-          </a:p>
+            <a:r>
+              <a:rPr lang="en-US" sz="1200" dirty="0">
+                <a:latin typeface="Arial" panose="020B0604020202020204" pitchFamily="34" charset="0"/>
+                <a:cs typeface="Arial" panose="020B0604020202020204" pitchFamily="34" charset="0"/>
+              </a:rPr>
+              <a:t>Claude Code agent with MCP Playwright validated selectors, generated Gherkin + POM code, and fixed 3 bugs.</a:t>
+            </a:r>
+          </a:p>
+        </p:txBody>
+      </p:sp>
+      <p:sp>
+        <p:nvSpPr>
+          <p:cNvPr id="12" name="Text 9"/>
+          <p:cNvSpPr/>
+          <p:nvPr/>
+        </p:nvSpPr>
+        <p:spPr>
+          <a:xfrm>
+            <a:off x="457200" y="3374136"/>
+            <a:ext cx="3931920" cy="256032"/>
+          </a:xfrm>
+          <a:prstGeom prst="rect">
+            <a:avLst/>
+          </a:prstGeom>
+          <a:noFill/>
+          <a:ln/>
+        </p:spPr>
+        <p:txBody>
+          <a:bodyPr wrap="square" rtlCol="0" anchor="ctr"/>
+          <a:lstStyle/>
           <a:p>
             <a:pPr marL="0" indent="0" algn="l">
               <a:buNone/>
             </a:pPr>
-            <a:endParaRPr lang="en-US" sz="1100"/>
-            <a:r>
-              <a:rPr lang="en-US" dirty="0"/>
-              <a:t>validated selectors, generated Gherkin + POM code, and fixed 3 bugs.</a:t>
-            </a:r>
-          </a:p>
-        </p:txBody>
-      </p:sp>
-      <p:sp>
-        <p:nvSpPr>
-          <p:cNvPr id="12" name="Text 9"/>
-          <p:cNvSpPr/>
-          <p:nvPr/>
-        </p:nvSpPr>
-        <p:spPr>
-          <a:xfrm>
-            <a:off x="457200" y="3374136"/>
-            <a:ext cx="3931920" cy="256032"/>
-          </a:xfrm>
-          <a:prstGeom prst="rect">
-            <a:avLst/>
-          </a:prstGeom>
-          <a:noFill/>
-          <a:ln/>
-        </p:spPr>
-        <p:txBody>
-          <a:bodyPr wrap="square" rtlCol="0" anchor="ctr"/>
-          <a:lstStyle/>
-          <a:p>
-            <a:pPr marL="0" indent="0" algn="l">
-              <a:buNone/>
-            </a:pPr>
             <a:endParaRPr lang="en-US" sz="1200"/>
-            <a:r>
-              <a:rPr lang="en-US" dirty="0"/>
-              <a:t>Quantified business impact</a:t>
-            </a:r>
           </a:p>
         </p:txBody>
       </p:sp>
@@ -7427,8 +8268,8 @@
         </p:nvSpPr>
         <p:spPr>
           <a:xfrm>
-            <a:off x="457200" y="3630168"/>
-            <a:ext cx="3977640" cy="457200"/>
+            <a:off x="502920" y="3774780"/>
+            <a:ext cx="3977640" cy="941832"/>
           </a:xfrm>
           <a:prstGeom prst="roundRect">
             <a:avLst>
@@ -7461,7 +8302,7 @@
         </p:nvSpPr>
         <p:spPr>
           <a:xfrm>
-            <a:off x="566928" y="3630168"/>
+            <a:off x="630936" y="3980520"/>
             <a:ext cx="3758184" cy="457200"/>
           </a:xfrm>
           <a:prstGeom prst="rect">
@@ -7477,9 +8318,11 @@
             <a:pPr marL="0" indent="0" algn="l">
               <a:buNone/>
             </a:pPr>
-            <a:endParaRPr lang="en-US" sz="1100"/>
-            <a:r>
-              <a:rPr lang="en-US" dirty="0"/>
+            <a:r>
+              <a:rPr lang="en-US" sz="1200" dirty="0">
+                <a:latin typeface="Arial" panose="020B0604020202020204" pitchFamily="34" charset="0"/>
+                <a:cs typeface="Arial" panose="020B0604020202020204" pitchFamily="34" charset="0"/>
+              </a:rPr>
               <a:t>8/8 Cypress + 8/8 Playwright tests passing.</a:t>
             </a:r>
           </a:p>
@@ -7487,9 +8330,11 @@
             <a:pPr marL="0" indent="0" algn="l">
               <a:buNone/>
             </a:pPr>
-            <a:endParaRPr lang="en-US" sz="1100"/>
-            <a:r>
-              <a:rPr lang="en-US" dirty="0"/>
+            <a:r>
+              <a:rPr lang="en-US" sz="1200" dirty="0">
+                <a:latin typeface="Arial" panose="020B0604020202020204" pitchFamily="34" charset="0"/>
+                <a:cs typeface="Arial" panose="020B0604020202020204" pitchFamily="34" charset="0"/>
+              </a:rPr>
               <a:t>Migration: 2-3 days manual -&gt; 3.5 h agent session (75% time reduction).</a:t>
             </a:r>
           </a:p>
@@ -7497,9 +8342,11 @@
             <a:pPr marL="0" indent="0" algn="l">
               <a:buNone/>
             </a:pPr>
-            <a:endParaRPr lang="en-US" sz="1100"/>
-            <a:r>
-              <a:rPr lang="en-US" dirty="0"/>
+            <a:r>
+              <a:rPr lang="en-US" sz="1200" dirty="0">
+                <a:latin typeface="Arial" panose="020B0604020202020204" pitchFamily="34" charset="0"/>
+                <a:cs typeface="Arial" panose="020B0604020202020204" pitchFamily="34" charset="0"/>
+              </a:rPr>
               <a:t>3 failure modes caught &amp; fixed autonomously.</a:t>
             </a:r>
           </a:p>
@@ -7559,7 +8406,7 @@
               <a:buNone/>
             </a:pPr>
             <a:r>
-              <a:rPr lang="en-US" sz="1300" b="1">
+              <a:rPr lang="en-US" sz="1300" b="1" dirty="0">
                 <a:solidFill>
                   <a:srgbClr val="FFFFFF"/>
                 </a:solidFill>
@@ -7569,7 +8416,7 @@
               </a:rPr>
               <a:t>OPTION 2 — Platform Contribution</a:t>
             </a:r>
-            <a:endParaRPr lang="en-US" sz="1300"/>
+            <a:endParaRPr lang="en-US" sz="1300" dirty="0"/>
           </a:p>
         </p:txBody>
       </p:sp>
@@ -7671,10 +8518,6 @@
               <a:buNone/>
             </a:pPr>
             <a:endParaRPr lang="en-US" sz="1100"/>
-            <a:r>
-              <a:rPr lang="en-US" dirty="0"/>
-              <a:t>N/A — Option 4 submission</a:t>
-            </a:r>
           </a:p>
         </p:txBody>
       </p:sp>
@@ -7776,10 +8619,6 @@
               <a:buNone/>
             </a:pPr>
             <a:endParaRPr lang="en-US" sz="1100"/>
-            <a:r>
-              <a:rPr lang="en-US" dirty="0"/>
-              <a:t>N/A</a:t>
-            </a:r>
           </a:p>
         </p:txBody>
       </p:sp>
@@ -7881,49 +8720,6 @@
               <a:buNone/>
             </a:pPr>
             <a:endParaRPr lang="en-US" sz="1100"/>
-            <a:r>
-              <a:rPr lang="en-US" dirty="0"/>
-              <a:t>N/A</a:t>
-            </a:r>
-          </a:p>
-        </p:txBody>
-      </p:sp>
-      <p:sp>
-        <p:nvSpPr>
-          <p:cNvPr id="26" name="Text 23"/>
-          <p:cNvSpPr/>
-          <p:nvPr/>
-        </p:nvSpPr>
-        <p:spPr>
-          <a:xfrm>
-            <a:off x="457200" y="4709160"/>
-            <a:ext cx="8229600" cy="274320"/>
-          </a:xfrm>
-          <a:prstGeom prst="rect">
-            <a:avLst/>
-          </a:prstGeom>
-          <a:noFill/>
-          <a:ln/>
-        </p:spPr>
-        <p:txBody>
-          <a:bodyPr wrap="square" rtlCol="0" anchor="ctr"/>
-          <a:lstStyle/>
-          <a:p>
-            <a:pPr marL="0" indent="0">
-              <a:buNone/>
-            </a:pPr>
-            <a:r>
-              <a:rPr lang="en-US" sz="1000" i="1">
-                <a:solidFill>
-                  <a:srgbClr val="5A6B72"/>
-                </a:solidFill>
-                <a:latin typeface="Calibri" pitchFamily="34" charset="0"/>
-                <a:ea typeface="Calibri" pitchFamily="34" charset="-122"/>
-                <a:cs typeface="Calibri" pitchFamily="34" charset="-120"/>
-              </a:rPr>
-              <a:t>Fill only the column for your option.</a:t>
-            </a:r>
-            <a:endParaRPr lang="en-US" sz="1000"/>
           </a:p>
         </p:txBody>
       </p:sp>
@@ -8120,10 +8916,12 @@
             <a:pPr marL="0" indent="0" algn="l">
               <a:buNone/>
             </a:pPr>
-            <a:endParaRPr lang="en-US" sz="1100"/>
-            <a:r>
-              <a:rPr lang="en-US" dirty="0"/>
-              <a:t>Migrate a 7-requirement Cypress TypeScript suite to Playwright Python BDD in one agent session — zero manual selector work, passing on first run.</a:t>
+            <a:r>
+              <a:rPr lang="en-US" sz="1200" dirty="0">
+                <a:latin typeface="Arial" panose="020B0604020202020204" pitchFamily="34" charset="0"/>
+                <a:cs typeface="Arial" panose="020B0604020202020204" pitchFamily="34" charset="0"/>
+              </a:rPr>
+              <a:t>Migrate a 7-requirement Cypress TypeScript suite to Playwright Python BDD in one agent session - zero manual selector work, passing on first run.</a:t>
             </a:r>
           </a:p>
         </p:txBody>
@@ -8137,7 +8935,7 @@
         <p:spPr>
           <a:xfrm>
             <a:off x="457200" y="2057400"/>
-            <a:ext cx="1572768" cy="2194560"/>
+            <a:ext cx="1572768" cy="2811780"/>
           </a:xfrm>
           <a:prstGeom prst="roundRect">
             <a:avLst>
@@ -8225,14 +9023,14 @@
       </p:sp>
       <p:sp>
         <p:nvSpPr>
-          <p:cNvPr id="10" name="Text 7"/>
-          <p:cNvSpPr/>
-          <p:nvPr/>
-        </p:nvSpPr>
-        <p:spPr>
-          <a:xfrm>
-            <a:off x="512064" y="2697480"/>
-            <a:ext cx="1463040" cy="274320"/>
+          <p:cNvPr id="11" name="Text 8"/>
+          <p:cNvSpPr/>
+          <p:nvPr/>
+        </p:nvSpPr>
+        <p:spPr>
+          <a:xfrm>
+            <a:off x="530352" y="3093120"/>
+            <a:ext cx="1426464" cy="1097280"/>
           </a:xfrm>
           <a:prstGeom prst="rect">
             <a:avLst/>
@@ -8247,41 +9045,11 @@
             <a:pPr marL="0" indent="0" algn="ctr">
               <a:buNone/>
             </a:pPr>
-            <a:endParaRPr lang="en-US" sz="1100"/>
-            <a:r>
-              <a:rPr lang="en-US" dirty="0"/>
-              <a:t>Requirements Analysis</a:t>
-            </a:r>
-          </a:p>
-        </p:txBody>
-      </p:sp>
-      <p:sp>
-        <p:nvSpPr>
-          <p:cNvPr id="11" name="Text 8"/>
-          <p:cNvSpPr/>
-          <p:nvPr/>
-        </p:nvSpPr>
-        <p:spPr>
-          <a:xfrm>
-            <a:off x="530352" y="3017520"/>
-            <a:ext cx="1426464" cy="1097280"/>
-          </a:xfrm>
-          <a:prstGeom prst="rect">
-            <a:avLst/>
-          </a:prstGeom>
-          <a:noFill/>
-          <a:ln/>
-        </p:spPr>
-        <p:txBody>
-          <a:bodyPr wrap="square" rtlCol="0" anchor="ctr"/>
-          <a:lstStyle/>
-          <a:p>
-            <a:pPr marL="0" indent="0" algn="ctr">
-              <a:buNone/>
-            </a:pPr>
-            <a:endParaRPr lang="en-US" sz="950"/>
-            <a:r>
-              <a:rPr lang="en-US" dirty="0"/>
+            <a:r>
+              <a:rPr lang="en-US" sz="1200" dirty="0">
+                <a:latin typeface="Arial" panose="020B0604020202020204" pitchFamily="34" charset="0"/>
+                <a:cs typeface="Arial" panose="020B0604020202020204" pitchFamily="34" charset="0"/>
+              </a:rPr>
               <a:t>Claude Code reads functional_requirements.md and all Cypress specs; extracts test intent per REQ-ID without executing any browser yet.</a:t>
             </a:r>
           </a:p>
@@ -8296,7 +9064,7 @@
         <p:spPr>
           <a:xfrm>
             <a:off x="2148840" y="2057400"/>
-            <a:ext cx="1572768" cy="2194560"/>
+            <a:ext cx="1572768" cy="2811780"/>
           </a:xfrm>
           <a:prstGeom prst="roundRect">
             <a:avLst>
@@ -8390,7 +9158,7 @@
         </p:nvSpPr>
         <p:spPr>
           <a:xfrm>
-            <a:off x="2203704" y="2697480"/>
+            <a:off x="2203704" y="2782656"/>
             <a:ext cx="1463040" cy="274320"/>
           </a:xfrm>
           <a:prstGeom prst="rect">
@@ -8406,9 +9174,11 @@
             <a:pPr marL="0" indent="0" algn="ctr">
               <a:buNone/>
             </a:pPr>
-            <a:endParaRPr lang="en-US" sz="1100"/>
-            <a:r>
-              <a:rPr lang="en-US" dirty="0"/>
+            <a:r>
+              <a:rPr lang="en-US" sz="1200" b="1" dirty="0">
+                <a:latin typeface="Arial" panose="020B0604020202020204" pitchFamily="34" charset="0"/>
+                <a:cs typeface="Arial" panose="020B0604020202020204" pitchFamily="34" charset="0"/>
+              </a:rPr>
               <a:t>MCP Playwright Exploration</a:t>
             </a:r>
           </a:p>
@@ -8422,7 +9192,7 @@
         </p:nvSpPr>
         <p:spPr>
           <a:xfrm>
-            <a:off x="2221992" y="3017520"/>
+            <a:off x="2240280" y="3423798"/>
             <a:ext cx="1426464" cy="1097280"/>
           </a:xfrm>
           <a:prstGeom prst="rect">
@@ -8438,10 +9208,12 @@
             <a:pPr marL="0" indent="0" algn="ctr">
               <a:buNone/>
             </a:pPr>
-            <a:endParaRPr lang="en-US" sz="950"/>
-            <a:r>
-              <a:rPr lang="en-US" dirty="0"/>
-              <a:t>Agent navigates live OrangeHRM via browser_snapshot + browser_evaluate; validates every selector against real DOM (count must equal 1) before writing code.</a:t>
+            <a:r>
+              <a:rPr lang="en-US" sz="1200" dirty="0">
+                <a:latin typeface="Arial" panose="020B0604020202020204" pitchFamily="34" charset="0"/>
+                <a:cs typeface="Arial" panose="020B0604020202020204" pitchFamily="34" charset="0"/>
+              </a:rPr>
+              <a:t>Agent navigates live OrangeHRM via browser_ snapshot + browser_evaluate; validates every selector against real DOM.</a:t>
             </a:r>
           </a:p>
         </p:txBody>
@@ -8455,7 +9227,7 @@
         <p:spPr>
           <a:xfrm>
             <a:off x="3840480" y="2057400"/>
-            <a:ext cx="1572768" cy="2194560"/>
+            <a:ext cx="1572768" cy="2811780"/>
           </a:xfrm>
           <a:prstGeom prst="roundRect">
             <a:avLst>
@@ -8565,9 +9337,11 @@
             <a:pPr marL="0" indent="0" algn="ctr">
               <a:buNone/>
             </a:pPr>
-            <a:endParaRPr lang="en-US" sz="1100"/>
-            <a:r>
-              <a:rPr lang="en-US" dirty="0"/>
+            <a:r>
+              <a:rPr lang="en-US" sz="1200" b="1" dirty="0">
+                <a:latin typeface="Arial" panose="020B0604020202020204" pitchFamily="34" charset="0"/>
+                <a:cs typeface="Arial" panose="020B0604020202020204" pitchFamily="34" charset="0"/>
+              </a:rPr>
               <a:t>Code Generation</a:t>
             </a:r>
           </a:p>
@@ -8581,7 +9355,7 @@
         </p:nvSpPr>
         <p:spPr>
           <a:xfrm>
-            <a:off x="3913632" y="3017520"/>
+            <a:off x="3895344" y="3420198"/>
             <a:ext cx="1426464" cy="1097280"/>
           </a:xfrm>
           <a:prstGeom prst="rect">
@@ -8597,9 +9371,11 @@
             <a:pPr marL="0" indent="0" algn="ctr">
               <a:buNone/>
             </a:pPr>
-            <a:endParaRPr lang="en-US" sz="950"/>
-            <a:r>
-              <a:rPr lang="en-US" dirty="0"/>
+            <a:r>
+              <a:rPr lang="en-US" sz="1200" dirty="0">
+                <a:latin typeface="Arial" panose="020B0604020202020204" pitchFamily="34" charset="0"/>
+                <a:cs typeface="Arial" panose="020B0604020202020204" pitchFamily="34" charset="0"/>
+              </a:rPr>
               <a:t>Agent writes three artifacts per REQ: Gherkin .feature file, Python Page Object class (POM), and pytest-bdd step definitions.</a:t>
             </a:r>
           </a:p>
@@ -8614,7 +9390,7 @@
         <p:spPr>
           <a:xfrm>
             <a:off x="5532120" y="2057400"/>
-            <a:ext cx="1572768" cy="2194560"/>
+            <a:ext cx="1572768" cy="2811780"/>
           </a:xfrm>
           <a:prstGeom prst="roundRect">
             <a:avLst>
@@ -8708,8 +9484,8 @@
         </p:nvSpPr>
         <p:spPr>
           <a:xfrm>
-            <a:off x="5586984" y="2697480"/>
-            <a:ext cx="1463040" cy="274320"/>
+            <a:off x="5422392" y="2688336"/>
+            <a:ext cx="1822824" cy="274320"/>
           </a:xfrm>
           <a:prstGeom prst="rect">
             <a:avLst/>
@@ -8724,9 +9500,11 @@
             <a:pPr marL="0" indent="0" algn="ctr">
               <a:buNone/>
             </a:pPr>
-            <a:endParaRPr lang="en-US" sz="1100"/>
-            <a:r>
-              <a:rPr lang="en-US" dirty="0"/>
+            <a:r>
+              <a:rPr lang="en-US" sz="1200" b="1" dirty="0">
+                <a:latin typeface="Arial" panose="020B0604020202020204" pitchFamily="34" charset="0"/>
+                <a:cs typeface="Arial" panose="020B0604020202020204" pitchFamily="34" charset="0"/>
+              </a:rPr>
               <a:t>Execution &amp; Validation</a:t>
             </a:r>
           </a:p>
@@ -8740,7 +9518,7 @@
         </p:nvSpPr>
         <p:spPr>
           <a:xfrm>
-            <a:off x="5605272" y="3017520"/>
+            <a:off x="5605272" y="3420198"/>
             <a:ext cx="1426464" cy="1097280"/>
           </a:xfrm>
           <a:prstGeom prst="rect">
@@ -8756,9 +9534,11 @@
             <a:pPr marL="0" indent="0" algn="ctr">
               <a:buNone/>
             </a:pPr>
-            <a:endParaRPr lang="en-US" sz="950"/>
-            <a:r>
-              <a:rPr lang="en-US" dirty="0"/>
+            <a:r>
+              <a:rPr lang="en-US" sz="1200" dirty="0">
+                <a:latin typeface="Arial" panose="020B0604020202020204" pitchFamily="34" charset="0"/>
+                <a:cs typeface="Arial" panose="020B0604020202020204" pitchFamily="34" charset="0"/>
+              </a:rPr>
               <a:t>pytest run; agent reads stdout/HTML report; on failure diagnoses root cause from URL + DOM state and patches the affected POM method.</a:t>
             </a:r>
           </a:p>
@@ -8773,7 +9553,7 @@
         <p:spPr>
           <a:xfrm>
             <a:off x="7223760" y="2057400"/>
-            <a:ext cx="1572768" cy="2194560"/>
+            <a:ext cx="1572768" cy="2811780"/>
           </a:xfrm>
           <a:prstGeom prst="roundRect">
             <a:avLst>
@@ -8867,8 +9647,8 @@
         </p:nvSpPr>
         <p:spPr>
           <a:xfrm>
-            <a:off x="7278624" y="2697480"/>
-            <a:ext cx="1463040" cy="274320"/>
+            <a:off x="7168896" y="2627406"/>
+            <a:ext cx="1627632" cy="274320"/>
           </a:xfrm>
           <a:prstGeom prst="rect">
             <a:avLst/>
@@ -8883,9 +9663,11 @@
             <a:pPr marL="0" indent="0" algn="ctr">
               <a:buNone/>
             </a:pPr>
-            <a:endParaRPr lang="en-US" sz="1100"/>
-            <a:r>
-              <a:rPr lang="en-US" dirty="0"/>
+            <a:r>
+              <a:rPr lang="en-US" sz="1200" b="1" dirty="0">
+                <a:latin typeface="Arial" panose="020B0604020202020204" pitchFamily="34" charset="0"/>
+                <a:cs typeface="Arial" panose="020B0604020202020204" pitchFamily="34" charset="0"/>
+              </a:rPr>
               <a:t>Evidence &amp; Commit</a:t>
             </a:r>
           </a:p>
@@ -8899,7 +9681,7 @@
         </p:nvSpPr>
         <p:spPr>
           <a:xfrm>
-            <a:off x="7296912" y="3017520"/>
+            <a:off x="7278624" y="3371850"/>
             <a:ext cx="1426464" cy="1097280"/>
           </a:xfrm>
           <a:prstGeom prst="rect">
@@ -8915,50 +9697,13 @@
             <a:pPr marL="0" indent="0" algn="ctr">
               <a:buNone/>
             </a:pPr>
-            <a:endParaRPr lang="en-US" sz="950"/>
-            <a:r>
-              <a:rPr lang="en-US" dirty="0"/>
-              <a:t>HTML report saved to reports/playwright/; session transcript JSONL serves as observability trace; changes committed to feature/migration-progress.</a:t>
-            </a:r>
-          </a:p>
-        </p:txBody>
-      </p:sp>
-      <p:sp>
-        <p:nvSpPr>
-          <p:cNvPr id="32" name="Text 29"/>
-          <p:cNvSpPr/>
-          <p:nvPr/>
-        </p:nvSpPr>
-        <p:spPr>
-          <a:xfrm>
-            <a:off x="457200" y="4389120"/>
-            <a:ext cx="8229600" cy="274320"/>
-          </a:xfrm>
-          <a:prstGeom prst="rect">
-            <a:avLst/>
-          </a:prstGeom>
-          <a:noFill/>
-          <a:ln/>
-        </p:spPr>
-        <p:txBody>
-          <a:bodyPr wrap="square" rtlCol="0" anchor="ctr"/>
-          <a:lstStyle/>
-          <a:p>
-            <a:pPr marL="0" indent="0">
-              <a:buNone/>
-            </a:pPr>
-            <a:r>
-              <a:rPr lang="en-US" sz="1000" i="1">
-                <a:solidFill>
-                  <a:srgbClr val="5A6B72"/>
-                </a:solidFill>
-                <a:latin typeface="Calibri" pitchFamily="34" charset="0"/>
-                <a:ea typeface="Calibri" pitchFamily="34" charset="-122"/>
-                <a:cs typeface="Calibri" pitchFamily="34" charset="-120"/>
-              </a:rPr>
-              <a:t>Add or remove steps to match your actual workflow.</a:t>
-            </a:r>
-            <a:endParaRPr lang="en-US" sz="1000"/>
+            <a:r>
+              <a:rPr lang="en-US" sz="1200" dirty="0">
+                <a:latin typeface="Arial" panose="020B0604020202020204" pitchFamily="34" charset="0"/>
+                <a:cs typeface="Arial" panose="020B0604020202020204" pitchFamily="34" charset="0"/>
+              </a:rPr>
+              <a:t>HTML report saved to reports/playwright/; session transcript JSONL serves as observability trace; changes committed to branch L2.</a:t>
+            </a:r>
           </a:p>
         </p:txBody>
       </p:sp>
@@ -9112,7 +9857,7 @@
               <a:buNone/>
             </a:pPr>
             <a:r>
-              <a:rPr lang="en-US" sz="1400" b="1">
+              <a:rPr lang="en-US" sz="1400" b="1" dirty="0">
                 <a:solidFill>
                   <a:srgbClr val="FFFFFF"/>
                 </a:solidFill>
@@ -9122,7 +9867,7 @@
               </a:rPr>
               <a:t>BEFORE — The Manual Way</a:t>
             </a:r>
-            <a:endParaRPr lang="en-US" sz="1400"/>
+            <a:endParaRPr lang="en-US" sz="1400" dirty="0"/>
           </a:p>
         </p:txBody>
       </p:sp>
@@ -9146,6 +9891,22 @@
         <p:txBody>
           <a:bodyPr wrap="square" rtlCol="0" anchor="t"/>
           <a:lstStyle/>
+          <a:p>
+            <a:pPr>
+              <a:spcAft>
+                <a:spcPts val="600"/>
+              </a:spcAft>
+              <a:buSzPct val="100000"/>
+            </a:pPr>
+            <a:endParaRPr lang="en-US" sz="1200" dirty="0">
+              <a:solidFill>
+                <a:srgbClr val="1B2227"/>
+              </a:solidFill>
+              <a:latin typeface="Calibri" pitchFamily="34" charset="0"/>
+              <a:ea typeface="Calibri" pitchFamily="34" charset="-122"/>
+              <a:cs typeface="Calibri" pitchFamily="34" charset="-120"/>
+            </a:endParaRPr>
+          </a:p>
           <a:p>
             <a:pPr marL="152400" indent="-152400">
               <a:spcAft>
@@ -9155,7 +9916,7 @@
               <a:buChar char="•"/>
             </a:pPr>
             <a:r>
-              <a:rPr lang="en-US" sz="1200">
+              <a:rPr lang="en-US" sz="1200" dirty="0">
                 <a:solidFill>
                   <a:srgbClr val="1B2227"/>
                 </a:solidFill>
@@ -9163,9 +9924,8 @@
                 <a:ea typeface="Calibri" pitchFamily="34" charset="-122"/>
                 <a:cs typeface="Calibri" pitchFamily="34" charset="-120"/>
               </a:rPr>
-              <a:t>Step-by-step manual process</a:t>
-            </a:r>
-            <a:endParaRPr lang="en-US" sz="1200"/>
+              <a:t>1) Read each Cypress spec and understand selector intent</a:t>
+            </a:r>
           </a:p>
           <a:p>
             <a:pPr marL="152400" indent="-152400">
@@ -9176,7 +9936,7 @@
               <a:buChar char="•"/>
             </a:pPr>
             <a:r>
-              <a:rPr lang="en-US" sz="1200">
+              <a:rPr lang="en-US" sz="1200" dirty="0">
                 <a:solidFill>
                   <a:srgbClr val="1B2227"/>
                 </a:solidFill>
@@ -9184,9 +9944,30 @@
                 <a:ea typeface="Calibri" pitchFamily="34" charset="-122"/>
                 <a:cs typeface="Calibri" pitchFamily="34" charset="-120"/>
               </a:rPr>
-              <a:t>Time taken (hrs / min)</a:t>
-            </a:r>
-            <a:endParaRPr lang="en-US" sz="1200"/>
+              <a:t>2) Open browser </a:t>
+            </a:r>
+            <a:r>
+              <a:rPr lang="en-US" sz="1200" dirty="0" err="1">
+                <a:solidFill>
+                  <a:srgbClr val="1B2227"/>
+                </a:solidFill>
+                <a:latin typeface="Calibri" pitchFamily="34" charset="0"/>
+                <a:ea typeface="Calibri" pitchFamily="34" charset="-122"/>
+                <a:cs typeface="Calibri" pitchFamily="34" charset="-120"/>
+              </a:rPr>
+              <a:t>DevTools</a:t>
+            </a:r>
+            <a:r>
+              <a:rPr lang="en-US" sz="1200" dirty="0">
+                <a:solidFill>
+                  <a:srgbClr val="1B2227"/>
+                </a:solidFill>
+                <a:latin typeface="Calibri" pitchFamily="34" charset="0"/>
+                <a:ea typeface="Calibri" pitchFamily="34" charset="-122"/>
+                <a:cs typeface="Calibri" pitchFamily="34" charset="-120"/>
+              </a:rPr>
+              <a:t>, locate and test each selector</a:t>
+            </a:r>
           </a:p>
           <a:p>
             <a:pPr marL="152400" indent="-152400">
@@ -9197,7 +9978,7 @@
               <a:buChar char="•"/>
             </a:pPr>
             <a:r>
-              <a:rPr lang="en-US" sz="1200">
+              <a:rPr lang="en-US" sz="1200" dirty="0">
                 <a:solidFill>
                   <a:srgbClr val="1B2227"/>
                 </a:solidFill>
@@ -9205,9 +9986,8 @@
                 <a:ea typeface="Calibri" pitchFamily="34" charset="-122"/>
                 <a:cs typeface="Calibri" pitchFamily="34" charset="-120"/>
               </a:rPr>
-              <a:t>Pain points &amp; error risks</a:t>
-            </a:r>
-            <a:endParaRPr lang="en-US" sz="1200"/>
+              <a:t>3) Rewrite TypeScript Page Objects in Python (class by class)</a:t>
+            </a:r>
           </a:p>
           <a:p>
             <a:pPr marL="152400" indent="-152400">
@@ -9218,7 +9998,7 @@
               <a:buChar char="•"/>
             </a:pPr>
             <a:r>
-              <a:rPr lang="en-US" sz="1200">
+              <a:rPr lang="en-US" sz="1200" dirty="0">
                 <a:solidFill>
                   <a:srgbClr val="1B2227"/>
                 </a:solidFill>
@@ -9226,183 +10006,9 @@
                 <a:ea typeface="Calibri" pitchFamily="34" charset="-122"/>
                 <a:cs typeface="Calibri" pitchFamily="34" charset="-120"/>
               </a:rPr>
-              <a:t>Quality issues that occurred</a:t>
-            </a:r>
-            <a:endParaRPr lang="en-US" sz="1200"/>
-          </a:p>
-        </p:txBody>
-      </p:sp>
-      <p:sp>
-        <p:nvSpPr>
-          <p:cNvPr id="7" name="Shape 4"/>
-          <p:cNvSpPr/>
-          <p:nvPr/>
-        </p:nvSpPr>
-        <p:spPr>
-          <a:xfrm>
-            <a:off x="4709160" y="1097280"/>
-            <a:ext cx="3977640" cy="457200"/>
-          </a:xfrm>
-          <a:prstGeom prst="roundRect">
-            <a:avLst>
-              <a:gd name="adj" fmla="val 10000"/>
-            </a:avLst>
-          </a:prstGeom>
-          <a:solidFill>
-            <a:srgbClr val="075056"/>
-          </a:solidFill>
-          <a:ln/>
-        </p:spPr>
-        <p:txBody>
-          <a:bodyPr/>
-          <a:lstStyle/>
-          <a:p>
-            <a:endParaRPr lang="en-US"/>
-          </a:p>
-        </p:txBody>
-      </p:sp>
-      <p:sp>
-        <p:nvSpPr>
-          <p:cNvPr id="8" name="Text 5"/>
-          <p:cNvSpPr/>
-          <p:nvPr/>
-        </p:nvSpPr>
-        <p:spPr>
-          <a:xfrm>
-            <a:off x="4709160" y="1097280"/>
-            <a:ext cx="3977640" cy="457200"/>
-          </a:xfrm>
-          <a:prstGeom prst="rect">
-            <a:avLst/>
-          </a:prstGeom>
-          <a:noFill/>
-          <a:ln/>
-        </p:spPr>
-        <p:txBody>
-          <a:bodyPr wrap="square" rtlCol="0" anchor="ctr"/>
-          <a:lstStyle/>
-          <a:p>
-            <a:pPr marL="0" indent="0" algn="ctr">
-              <a:buNone/>
-            </a:pPr>
-            <a:endParaRPr lang="en-US" sz="1400"/>
-            <a:r>
-              <a:rPr lang="en-US" dirty="0"/>
-              <a:t>BEFORE — The Manual Way</a:t>
-            </a:r>
-          </a:p>
-          <a:p>
-            <a:pPr marL="0" indent="0" algn="ctr">
-              <a:buNone/>
-            </a:pPr>
-            <a:endParaRPr lang="en-US" sz="1400"/>
-            <a:r>
-              <a:rPr lang="en-US" dirty="0"/>
-              <a:t>1) Read each Cypress spec and understand selector intent</a:t>
-            </a:r>
-          </a:p>
-          <a:p>
-            <a:pPr marL="0" indent="0" algn="ctr">
-              <a:buNone/>
-            </a:pPr>
-            <a:endParaRPr lang="en-US" sz="1400"/>
-            <a:r>
-              <a:rPr lang="en-US" dirty="0"/>
-              <a:t>2) Open browser DevTools, locate and test each selector</a:t>
-            </a:r>
-          </a:p>
-          <a:p>
-            <a:pPr marL="0" indent="0" algn="ctr">
-              <a:buNone/>
-            </a:pPr>
-            <a:endParaRPr lang="en-US" sz="1400"/>
-            <a:r>
-              <a:rPr lang="en-US" dirty="0"/>
-              <a:t>3) Rewrite TypeScript Page Objects in Python (class by class)</a:t>
-            </a:r>
-          </a:p>
-          <a:p>
-            <a:pPr marL="0" indent="0" algn="ctr">
-              <a:buNone/>
-            </a:pPr>
-            <a:endParaRPr lang="en-US" sz="1400"/>
-            <a:r>
-              <a:rPr lang="en-US" dirty="0"/>
               <a:t>4) Author Gherkin .feature files from scratch per requirement</a:t>
             </a:r>
           </a:p>
-          <a:p>
-            <a:pPr marL="0" indent="0" algn="ctr">
-              <a:buNone/>
-            </a:pPr>
-            <a:endParaRPr lang="en-US" sz="1400"/>
-            <a:r>
-              <a:rPr lang="en-US" dirty="0"/>
-              <a:t>5) Debug import path issues and dependency conflicts</a:t>
-            </a:r>
-          </a:p>
-          <a:p>
-            <a:pPr marL="0" indent="0" algn="ctr">
-              <a:buNone/>
-            </a:pPr>
-            <a:endParaRPr lang="en-US" sz="1400"/>
-            <a:r>
-              <a:rPr lang="en-US" dirty="0"/>
-              <a:t>6) Diagnose Vue reactive timing gaps causing flaky assertions</a:t>
-            </a:r>
-          </a:p>
-          <a:p>
-            <a:pPr marL="0" indent="0" algn="ctr">
-              <a:buNone/>
-            </a:pPr>
-            <a:endParaRPr lang="en-US" sz="1400"/>
-            <a:r>
-              <a:rPr lang="en-US" dirty="0"/>
-              <a:t>Time: 2-3 days (est. 16-24 h) for 7 requirements</a:t>
-            </a:r>
-          </a:p>
-          <a:p>
-            <a:pPr marL="0" indent="0" algn="ctr">
-              <a:buNone/>
-            </a:pPr>
-            <a:endParaRPr lang="en-US" sz="1400"/>
-            <a:r>
-              <a:rPr lang="en-US" dirty="0"/>
-              <a:t>Pain points: selector drift, namespace collision, Vue render timing</a:t>
-            </a:r>
-          </a:p>
-          <a:p>
-            <a:pPr marL="0" indent="0" algn="ctr">
-              <a:buNone/>
-            </a:pPr>
-            <a:endParaRPr lang="en-US" sz="1400"/>
-            <a:r>
-              <a:rPr lang="en-US" dirty="0"/>
-              <a:t>Quality: 3 known bug patterns went undetected in L1 manual review</a:t>
-            </a:r>
-          </a:p>
-        </p:txBody>
-      </p:sp>
-      <p:sp>
-        <p:nvSpPr>
-          <p:cNvPr id="9" name="Text 6"/>
-          <p:cNvSpPr/>
-          <p:nvPr/>
-        </p:nvSpPr>
-        <p:spPr>
-          <a:xfrm>
-            <a:off x="4800600" y="1691640"/>
-            <a:ext cx="3794760" cy="2926080"/>
-          </a:xfrm>
-          <a:prstGeom prst="rect">
-            <a:avLst/>
-          </a:prstGeom>
-          <a:noFill/>
-          <a:ln/>
-        </p:spPr>
-        <p:txBody>
-          <a:bodyPr wrap="square" rtlCol="0" anchor="t"/>
-          <a:lstStyle/>
           <a:p>
             <a:pPr marL="152400" indent="-152400">
               <a:spcAft>
@@ -9411,10 +10017,16 @@
               <a:buSzPct val="100000"/>
               <a:buChar char="•"/>
             </a:pPr>
-            <a:endParaRPr lang="en-US" sz="1200"/>
-            <a:r>
-              <a:rPr lang="en-US" dirty="0"/>
-              <a:t>AFTER — The AI-Assisted Way</a:t>
+            <a:r>
+              <a:rPr lang="en-US" sz="1200" dirty="0">
+                <a:solidFill>
+                  <a:srgbClr val="1B2227"/>
+                </a:solidFill>
+                <a:latin typeface="Calibri" pitchFamily="34" charset="0"/>
+                <a:ea typeface="Calibri" pitchFamily="34" charset="-122"/>
+                <a:cs typeface="Calibri" pitchFamily="34" charset="-120"/>
+              </a:rPr>
+              <a:t>5) Debug import path issues and dependency conflicts</a:t>
             </a:r>
           </a:p>
           <a:p>
@@ -9425,10 +10037,16 @@
               <a:buSzPct val="100000"/>
               <a:buChar char="•"/>
             </a:pPr>
-            <a:endParaRPr lang="en-US" sz="1200"/>
-            <a:r>
-              <a:rPr lang="en-US" dirty="0"/>
-              <a:t>Claude Code agent: snapshot -&gt; validate selectors -&gt; generate POM -&gt; run pytest -&gt; patch</a:t>
+            <a:r>
+              <a:rPr lang="en-US" sz="1200" dirty="0">
+                <a:solidFill>
+                  <a:srgbClr val="1B2227"/>
+                </a:solidFill>
+                <a:latin typeface="Calibri" pitchFamily="34" charset="0"/>
+                <a:ea typeface="Calibri" pitchFamily="34" charset="-122"/>
+                <a:cs typeface="Calibri" pitchFamily="34" charset="-120"/>
+              </a:rPr>
+              <a:t>6) Diagnose Vue reactive timing gaps causing flaky assertions</a:t>
             </a:r>
           </a:p>
           <a:p>
@@ -9439,12 +10057,162 @@
               <a:buSzPct val="100000"/>
               <a:buChar char="•"/>
             </a:pPr>
-            <a:endParaRPr lang="en-US" sz="1200"/>
-            <a:r>
-              <a:rPr lang="en-US" dirty="0"/>
-              <a:t>2 patch cycles required (Employee ID conflict + Vue timing race)</a:t>
-            </a:r>
-          </a:p>
+            <a:r>
+              <a:rPr lang="en-US" sz="1200" dirty="0">
+                <a:solidFill>
+                  <a:srgbClr val="1B2227"/>
+                </a:solidFill>
+                <a:latin typeface="Calibri" pitchFamily="34" charset="0"/>
+                <a:ea typeface="Calibri" pitchFamily="34" charset="-122"/>
+                <a:cs typeface="Calibri" pitchFamily="34" charset="-120"/>
+              </a:rPr>
+              <a:t>Time: 2-3 days (est. 16-24 h) for 7 requirements</a:t>
+            </a:r>
+          </a:p>
+        </p:txBody>
+      </p:sp>
+      <p:sp>
+        <p:nvSpPr>
+          <p:cNvPr id="7" name="Shape 4"/>
+          <p:cNvSpPr/>
+          <p:nvPr/>
+        </p:nvSpPr>
+        <p:spPr>
+          <a:xfrm>
+            <a:off x="4800600" y="1097280"/>
+            <a:ext cx="3977640" cy="457200"/>
+          </a:xfrm>
+          <a:prstGeom prst="roundRect">
+            <a:avLst>
+              <a:gd name="adj" fmla="val 10000"/>
+            </a:avLst>
+          </a:prstGeom>
+          <a:solidFill>
+            <a:srgbClr val="075056"/>
+          </a:solidFill>
+          <a:ln/>
+        </p:spPr>
+        <p:txBody>
+          <a:bodyPr/>
+          <a:lstStyle/>
+          <a:p>
+            <a:r>
+              <a:rPr lang="en-US" sz="1400" b="1" dirty="0">
+                <a:solidFill>
+                  <a:srgbClr val="FFFFFF"/>
+                </a:solidFill>
+                <a:latin typeface="Arial" pitchFamily="34" charset="0"/>
+                <a:ea typeface="Arial" pitchFamily="34" charset="-122"/>
+                <a:cs typeface="Arial" pitchFamily="34" charset="-120"/>
+              </a:rPr>
+              <a:t>         AFTER - Agent-Driven Migration</a:t>
+            </a:r>
+            <a:endParaRPr lang="en-US" sz="1400" dirty="0"/>
+          </a:p>
+        </p:txBody>
+      </p:sp>
+      <p:sp>
+        <p:nvSpPr>
+          <p:cNvPr id="8" name="Text 5"/>
+          <p:cNvSpPr/>
+          <p:nvPr/>
+        </p:nvSpPr>
+        <p:spPr>
+          <a:xfrm>
+            <a:off x="4709160" y="1097280"/>
+            <a:ext cx="3977640" cy="457200"/>
+          </a:xfrm>
+          <a:prstGeom prst="rect">
+            <a:avLst/>
+          </a:prstGeom>
+          <a:noFill/>
+          <a:ln/>
+        </p:spPr>
+        <p:txBody>
+          <a:bodyPr wrap="square" rtlCol="0" anchor="ctr"/>
+          <a:lstStyle/>
+          <a:p>
+            <a:pPr marL="0" indent="0" algn="ctr">
+              <a:buNone/>
+            </a:pPr>
+            <a:endParaRPr lang="en-US" sz="1400"/>
+          </a:p>
+          <a:p>
+            <a:pPr marL="0" indent="0" algn="ctr">
+              <a:buNone/>
+            </a:pPr>
+            <a:endParaRPr lang="en-US" sz="1400"/>
+          </a:p>
+          <a:p>
+            <a:pPr marL="0" indent="0" algn="ctr">
+              <a:buNone/>
+            </a:pPr>
+            <a:endParaRPr lang="en-US" sz="1400"/>
+          </a:p>
+          <a:p>
+            <a:pPr marL="0" indent="0" algn="ctr">
+              <a:buNone/>
+            </a:pPr>
+            <a:endParaRPr lang="en-US" sz="1400"/>
+          </a:p>
+          <a:p>
+            <a:pPr marL="0" indent="0" algn="ctr">
+              <a:buNone/>
+            </a:pPr>
+            <a:endParaRPr lang="en-US" sz="1400"/>
+          </a:p>
+          <a:p>
+            <a:pPr marL="0" indent="0" algn="ctr">
+              <a:buNone/>
+            </a:pPr>
+            <a:endParaRPr lang="en-US" sz="1400"/>
+          </a:p>
+          <a:p>
+            <a:pPr marL="0" indent="0" algn="ctr">
+              <a:buNone/>
+            </a:pPr>
+            <a:endParaRPr lang="en-US" sz="1400"/>
+          </a:p>
+          <a:p>
+            <a:pPr marL="0" indent="0" algn="ctr">
+              <a:buNone/>
+            </a:pPr>
+            <a:endParaRPr lang="en-US" sz="1400"/>
+          </a:p>
+          <a:p>
+            <a:pPr marL="0" indent="0" algn="ctr">
+              <a:buNone/>
+            </a:pPr>
+            <a:endParaRPr lang="en-US" sz="1400"/>
+          </a:p>
+          <a:p>
+            <a:pPr marL="0" indent="0" algn="ctr">
+              <a:buNone/>
+            </a:pPr>
+            <a:endParaRPr lang="en-US" sz="1400"/>
+          </a:p>
+        </p:txBody>
+      </p:sp>
+      <p:sp>
+        <p:nvSpPr>
+          <p:cNvPr id="9" name="Text 6"/>
+          <p:cNvSpPr/>
+          <p:nvPr/>
+        </p:nvSpPr>
+        <p:spPr>
+          <a:xfrm>
+            <a:off x="4800600" y="1901542"/>
+            <a:ext cx="3794760" cy="2761898"/>
+          </a:xfrm>
+          <a:prstGeom prst="rect">
+            <a:avLst/>
+          </a:prstGeom>
+          <a:noFill/>
+          <a:ln/>
+        </p:spPr>
+        <p:txBody>
+          <a:bodyPr wrap="square" rtlCol="0" anchor="t"/>
+          <a:lstStyle/>
           <a:p>
             <a:pPr marL="152400" indent="-152400">
               <a:spcAft>
@@ -9453,10 +10221,12 @@
               <a:buSzPct val="100000"/>
               <a:buChar char="•"/>
             </a:pPr>
-            <a:endParaRPr lang="en-US" sz="1200"/>
-            <a:r>
-              <a:rPr lang="en-US" dirty="0"/>
-              <a:t>First-pass accuracy: ~80% (6/8 tests pass without manual intervention)</a:t>
+            <a:r>
+              <a:rPr lang="en-US" sz="1200" dirty="0">
+                <a:latin typeface="Arial" panose="020B0604020202020204" pitchFamily="34" charset="0"/>
+                <a:cs typeface="Arial" panose="020B0604020202020204" pitchFamily="34" charset="0"/>
+              </a:rPr>
+              <a:t>Claude Code agent: snapshot -&gt; validate selectors -&gt; generate POM -&gt; run pytest -&gt; patch</a:t>
             </a:r>
           </a:p>
           <a:p>
@@ -9467,10 +10237,12 @@
               <a:buSzPct val="100000"/>
               <a:buChar char="•"/>
             </a:pPr>
-            <a:endParaRPr lang="en-US" sz="1200"/>
-            <a:r>
-              <a:rPr lang="en-US" dirty="0"/>
-              <a:t>Time: 3.5 h total agent session for same 7 requirements</a:t>
+            <a:r>
+              <a:rPr lang="en-US" sz="1200" dirty="0">
+                <a:latin typeface="Arial" panose="020B0604020202020204" pitchFamily="34" charset="0"/>
+                <a:cs typeface="Arial" panose="020B0604020202020204" pitchFamily="34" charset="0"/>
+              </a:rPr>
+              <a:t>2 patch cycles required (Employee ID conflict + Vue timing race)</a:t>
             </a:r>
           </a:p>
           <a:p>
@@ -9481,9 +10253,43 @@
               <a:buSzPct val="100000"/>
               <a:buChar char="•"/>
             </a:pPr>
-            <a:endParaRPr lang="en-US" sz="1200"/>
-            <a:r>
-              <a:rPr lang="en-US" dirty="0"/>
+            <a:r>
+              <a:rPr lang="en-US" sz="1200" dirty="0">
+                <a:latin typeface="Arial" panose="020B0604020202020204" pitchFamily="34" charset="0"/>
+                <a:cs typeface="Arial" panose="020B0604020202020204" pitchFamily="34" charset="0"/>
+              </a:rPr>
+              <a:t>First-pass accuracy: ~80% (6/8 tests pass without manual intervention)</a:t>
+            </a:r>
+          </a:p>
+          <a:p>
+            <a:pPr marL="152400" indent="-152400">
+              <a:spcAft>
+                <a:spcPts val="600"/>
+              </a:spcAft>
+              <a:buSzPct val="100000"/>
+              <a:buChar char="•"/>
+            </a:pPr>
+            <a:r>
+              <a:rPr lang="en-US" sz="1200" dirty="0">
+                <a:latin typeface="Arial" panose="020B0604020202020204" pitchFamily="34" charset="0"/>
+                <a:cs typeface="Arial" panose="020B0604020202020204" pitchFamily="34" charset="0"/>
+              </a:rPr>
+              <a:t>Time: 3.5 h total agent session for same 7 requirements</a:t>
+            </a:r>
+          </a:p>
+          <a:p>
+            <a:pPr marL="152400" indent="-152400">
+              <a:spcAft>
+                <a:spcPts val="600"/>
+              </a:spcAft>
+              <a:buSzPct val="100000"/>
+              <a:buChar char="•"/>
+            </a:pPr>
+            <a:r>
+              <a:rPr lang="en-US" sz="1200" dirty="0">
+                <a:latin typeface="Arial" panose="020B0604020202020204" pitchFamily="34" charset="0"/>
+                <a:cs typeface="Arial" panose="020B0604020202020204" pitchFamily="34" charset="0"/>
+              </a:rPr>
               <a:t>75% time reduction vs. manual baseline</a:t>
             </a:r>
           </a:p>
@@ -9514,10 +10320,6 @@
               <a:buNone/>
             </a:pPr>
             <a:endParaRPr lang="en-US" sz="1000"/>
-            <a:r>
-              <a:rPr lang="en-US" dirty="0"/>
-              <a:t>See reports/playwright/report.html (8/8 passing, 82 s) and reports/cypress/ (8/8 passing, 1 m 43 s) for execution evidence.</a:t>
-            </a:r>
           </a:p>
         </p:txBody>
       </p:sp>
@@ -9531,15 +10333,7 @@
 
 <file path=ppt/slides/slide6.xml><?xml version="1.0" encoding="utf-8"?>
 <p:sld xmlns:a="http://schemas.openxmlformats.org/drawingml/2006/main" xmlns:r="http://schemas.openxmlformats.org/officeDocument/2006/relationships" xmlns:p="http://schemas.openxmlformats.org/presentationml/2006/main">
-  <p:cSld name="Slide 6">
-    <p:bg>
-      <p:bgPr>
-        <a:solidFill>
-          <a:srgbClr val="FFFFFF"/>
-        </a:solidFill>
-        <a:effectLst/>
-      </p:bgPr>
-    </p:bg>
+  <p:cSld>
     <p:spTree>
       <p:nvGrpSpPr>
         <p:cNvPr id="1" name=""/>
@@ -9623,17 +10417,11 @@
           <p:cNvGraphicFramePr>
             <a:graphicFrameLocks noGrp="1"/>
           </p:cNvGraphicFramePr>
-          <p:nvPr>
-            <p:extLst>
-              <p:ext uri="{D42A27DB-BD31-4B8C-83A1-F6EECF244321}">
-                <p14:modId xmlns:p14="http://schemas.microsoft.com/office/powerpoint/2010/main" val="1579011935"/>
-              </p:ext>
-            </p:extLst>
-          </p:nvPr>
+          <p:nvPr/>
         </p:nvGraphicFramePr>
         <p:xfrm>
           <a:off x="457200" y="1143000"/>
-          <a:ext cx="8229600" cy="2697480"/>
+          <a:ext cx="8229600" cy="2240280"/>
         </p:xfrm>
         <a:graphic>
           <a:graphicData uri="http://schemas.openxmlformats.org/drawingml/2006/table">
@@ -9957,15 +10745,22 @@
                       <a:pPr marL="0" indent="0">
                         <a:buNone/>
                       </a:pPr>
-                      <a:endParaRPr lang="en-US" sz="1200">
+                      <a:r>
+                        <a:rPr lang="en-US" sz="1200" dirty="0">
+                          <a:solidFill>
+                            <a:srgbClr val="1B2227"/>
+                          </a:solidFill>
+                          <a:latin typeface="Calibri" pitchFamily="34" charset="0"/>
+                          <a:ea typeface="Calibri" pitchFamily="34" charset="-122"/>
+                          <a:cs typeface="Calibri" pitchFamily="34" charset="-120"/>
+                        </a:rPr>
+                        <a:t>Scenarios in Cypress framework - Typescript</a:t>
+                      </a:r>
+                      <a:endParaRPr lang="en-US" sz="1200" dirty="0">
                         <a:latin typeface="Calibri" charset="0"/>
                         <a:ea typeface="Calibri" charset="0"/>
                         <a:cs typeface="Calibri" charset="0"/>
                       </a:endParaRPr>
-                      <a:r>
-                        <a:rPr lang="en-US" dirty="0"/>
-                        <a:t>Cypress -&gt; Playwright migration (7 reqs)</a:t>
-                      </a:r>
                     </a:p>
                   </a:txBody>
                   <a:tcPr anchor="ctr">
@@ -10018,15 +10813,22 @@
                       <a:pPr marL="0" indent="0">
                         <a:buNone/>
                       </a:pPr>
-                      <a:endParaRPr lang="en-US" sz="1200">
+                      <a:r>
+                        <a:rPr lang="en-US" sz="1200" dirty="0">
+                          <a:solidFill>
+                            <a:srgbClr val="1B2227"/>
+                          </a:solidFill>
+                          <a:latin typeface="Calibri" pitchFamily="34" charset="0"/>
+                          <a:ea typeface="Calibri" pitchFamily="34" charset="-122"/>
+                          <a:cs typeface="Calibri" pitchFamily="34" charset="-120"/>
+                        </a:rPr>
+                        <a:t>8 Hours</a:t>
+                      </a:r>
+                      <a:endParaRPr lang="en-US" sz="1200" dirty="0">
                         <a:latin typeface="Calibri" charset="0"/>
                         <a:ea typeface="Calibri" charset="0"/>
                         <a:cs typeface="Calibri" charset="0"/>
                       </a:endParaRPr>
-                      <a:r>
-                        <a:rPr lang="en-US" dirty="0"/>
-                        <a:t>16-24 hours</a:t>
-                      </a:r>
                     </a:p>
                   </a:txBody>
                   <a:tcPr anchor="ctr">
@@ -10079,15 +10881,22 @@
                       <a:pPr marL="0" indent="0">
                         <a:buNone/>
                       </a:pPr>
-                      <a:endParaRPr lang="en-US" sz="1200">
+                      <a:r>
+                        <a:rPr lang="en-US" sz="1200" dirty="0">
+                          <a:solidFill>
+                            <a:srgbClr val="1B2227"/>
+                          </a:solidFill>
+                          <a:latin typeface="Calibri" pitchFamily="34" charset="0"/>
+                          <a:ea typeface="Calibri" pitchFamily="34" charset="-122"/>
+                          <a:cs typeface="Calibri" pitchFamily="34" charset="-120"/>
+                        </a:rPr>
+                        <a:t>1 Hour</a:t>
+                      </a:r>
+                      <a:endParaRPr lang="en-US" sz="1200" dirty="0">
                         <a:latin typeface="Calibri" charset="0"/>
                         <a:ea typeface="Calibri" charset="0"/>
                         <a:cs typeface="Calibri" charset="0"/>
                       </a:endParaRPr>
-                      <a:r>
-                        <a:rPr lang="en-US" dirty="0"/>
-                        <a:t>3.5 hours</a:t>
-                      </a:r>
                     </a:p>
                   </a:txBody>
                   <a:tcPr anchor="ctr">
@@ -10140,15 +10949,22 @@
                       <a:pPr marL="0" indent="0">
                         <a:buNone/>
                       </a:pPr>
-                      <a:endParaRPr lang="en-US" sz="1200">
+                      <a:r>
+                        <a:rPr lang="en-US" sz="1200" dirty="0">
+                          <a:solidFill>
+                            <a:srgbClr val="1B2227"/>
+                          </a:solidFill>
+                          <a:latin typeface="Calibri" pitchFamily="34" charset="0"/>
+                          <a:ea typeface="Calibri" pitchFamily="34" charset="-122"/>
+                          <a:cs typeface="Calibri" pitchFamily="34" charset="-120"/>
+                        </a:rPr>
+                        <a:t>87,5 % Time saved</a:t>
+                      </a:r>
+                      <a:endParaRPr lang="en-US" sz="1200" dirty="0">
                         <a:latin typeface="Calibri" charset="0"/>
                         <a:ea typeface="Calibri" charset="0"/>
                         <a:cs typeface="Calibri" charset="0"/>
                       </a:endParaRPr>
-                      <a:r>
-                        <a:rPr lang="en-US" dirty="0"/>
-                        <a:t>~80% time saved</a:t>
-                      </a:r>
                     </a:p>
                   </a:txBody>
                   <a:tcPr anchor="ctr">
@@ -10208,15 +11024,22 @@
                       <a:pPr marL="0" indent="0">
                         <a:buNone/>
                       </a:pPr>
-                      <a:endParaRPr lang="en-US" sz="1200">
+                      <a:r>
+                        <a:rPr lang="en-US" sz="1200" dirty="0">
+                          <a:solidFill>
+                            <a:srgbClr val="1B2227"/>
+                          </a:solidFill>
+                          <a:latin typeface="Calibri" pitchFamily="34" charset="0"/>
+                          <a:ea typeface="Calibri" pitchFamily="34" charset="-122"/>
+                          <a:cs typeface="Calibri" pitchFamily="34" charset="-120"/>
+                        </a:rPr>
+                        <a:t>Scenarios in Playwright framework – BDD and Python</a:t>
+                      </a:r>
+                      <a:endParaRPr lang="en-US" sz="1200" dirty="0">
                         <a:latin typeface="Calibri" charset="0"/>
                         <a:ea typeface="Calibri" charset="0"/>
                         <a:cs typeface="Calibri" charset="0"/>
                       </a:endParaRPr>
-                      <a:r>
-                        <a:rPr lang="en-US" dirty="0"/>
-                        <a:t>Selector validation per requirement</a:t>
-                      </a:r>
                     </a:p>
                   </a:txBody>
                   <a:tcPr anchor="ctr">
@@ -10269,15 +11092,22 @@
                       <a:pPr marL="0" indent="0">
                         <a:buNone/>
                       </a:pPr>
-                      <a:endParaRPr lang="en-US" sz="1200">
+                      <a:r>
+                        <a:rPr lang="en-US" sz="1200" dirty="0">
+                          <a:solidFill>
+                            <a:srgbClr val="1B2227"/>
+                          </a:solidFill>
+                          <a:latin typeface="Calibri" pitchFamily="34" charset="0"/>
+                          <a:ea typeface="Calibri" pitchFamily="34" charset="-122"/>
+                          <a:cs typeface="Calibri" pitchFamily="34" charset="-120"/>
+                        </a:rPr>
+                        <a:t>12 Hours</a:t>
+                      </a:r>
+                      <a:endParaRPr lang="en-US" sz="1200" dirty="0">
                         <a:latin typeface="Calibri" charset="0"/>
                         <a:ea typeface="Calibri" charset="0"/>
                         <a:cs typeface="Calibri" charset="0"/>
                       </a:endParaRPr>
-                      <a:r>
-                        <a:rPr lang="en-US" dirty="0"/>
-                        <a:t>~20 min/req = 2.3 h total</a:t>
-                      </a:r>
                     </a:p>
                   </a:txBody>
                   <a:tcPr anchor="ctr">
@@ -10330,15 +11160,22 @@
                       <a:pPr marL="0" indent="0">
                         <a:buNone/>
                       </a:pPr>
-                      <a:endParaRPr lang="en-US" sz="1200">
+                      <a:r>
+                        <a:rPr lang="en-US" sz="1200" dirty="0">
+                          <a:solidFill>
+                            <a:srgbClr val="1B2227"/>
+                          </a:solidFill>
+                          <a:latin typeface="Calibri" pitchFamily="34" charset="0"/>
+                          <a:ea typeface="Calibri" pitchFamily="34" charset="-122"/>
+                          <a:cs typeface="Calibri" pitchFamily="34" charset="-120"/>
+                        </a:rPr>
+                        <a:t>1 Hour</a:t>
+                      </a:r>
+                      <a:endParaRPr lang="en-US" sz="1200" dirty="0">
                         <a:latin typeface="Calibri" charset="0"/>
                         <a:ea typeface="Calibri" charset="0"/>
                         <a:cs typeface="Calibri" charset="0"/>
                       </a:endParaRPr>
-                      <a:r>
-                        <a:rPr lang="en-US" dirty="0"/>
-                        <a:t>~3 min/req (MCP live nav)</a:t>
-                      </a:r>
                     </a:p>
                   </a:txBody>
                   <a:tcPr anchor="ctr">
@@ -10391,15 +11228,22 @@
                       <a:pPr marL="0" indent="0">
                         <a:buNone/>
                       </a:pPr>
-                      <a:endParaRPr lang="en-US" sz="1200">
+                      <a:r>
+                        <a:rPr lang="en-US" sz="1200" dirty="0">
+                          <a:solidFill>
+                            <a:srgbClr val="1B2227"/>
+                          </a:solidFill>
+                          <a:latin typeface="Calibri" pitchFamily="34" charset="0"/>
+                          <a:ea typeface="Calibri" pitchFamily="34" charset="-122"/>
+                          <a:cs typeface="Calibri" pitchFamily="34" charset="-120"/>
+                        </a:rPr>
+                        <a:t>91,6 % Time saved</a:t>
+                      </a:r>
+                      <a:endParaRPr lang="en-US" sz="1200" dirty="0">
                         <a:latin typeface="Calibri" charset="0"/>
                         <a:ea typeface="Calibri" charset="0"/>
                         <a:cs typeface="Calibri" charset="0"/>
                       </a:endParaRPr>
-                      <a:r>
-                        <a:rPr lang="en-US" dirty="0"/>
-                        <a:t>~85% per req</a:t>
-                      </a:r>
                     </a:p>
                   </a:txBody>
                   <a:tcPr anchor="ctr">
@@ -10459,15 +11303,22 @@
                       <a:pPr marL="0" indent="0">
                         <a:buNone/>
                       </a:pPr>
-                      <a:endParaRPr lang="en-US" sz="1200">
+                      <a:r>
+                        <a:rPr lang="en-US" sz="1200" dirty="0">
+                          <a:solidFill>
+                            <a:srgbClr val="1B2227"/>
+                          </a:solidFill>
+                          <a:latin typeface="Calibri" pitchFamily="34" charset="0"/>
+                          <a:ea typeface="Calibri" pitchFamily="34" charset="-122"/>
+                          <a:cs typeface="Calibri" pitchFamily="34" charset="-120"/>
+                        </a:rPr>
+                        <a:t>Quality / error rate</a:t>
+                      </a:r>
+                      <a:endParaRPr lang="en-US" sz="1200" dirty="0">
                         <a:latin typeface="Calibri" charset="0"/>
                         <a:ea typeface="Calibri" charset="0"/>
                         <a:cs typeface="Calibri" charset="0"/>
                       </a:endParaRPr>
-                      <a:r>
-                        <a:rPr lang="en-US" dirty="0"/>
-                        <a:t>Bug catch rate</a:t>
-                      </a:r>
                     </a:p>
                   </a:txBody>
                   <a:tcPr anchor="ctr">
@@ -10520,15 +11371,22 @@
                       <a:pPr marL="0" indent="0">
                         <a:buNone/>
                       </a:pPr>
-                      <a:endParaRPr lang="en-US" sz="1200">
+                      <a:r>
+                        <a:rPr lang="en-US" sz="1200" dirty="0">
+                          <a:solidFill>
+                            <a:srgbClr val="1B2227"/>
+                          </a:solidFill>
+                          <a:latin typeface="Calibri" pitchFamily="34" charset="0"/>
+                          <a:ea typeface="Calibri" pitchFamily="34" charset="-122"/>
+                          <a:cs typeface="Calibri" pitchFamily="34" charset="-120"/>
+                        </a:rPr>
+                        <a:t>Medium</a:t>
+                      </a:r>
+                      <a:endParaRPr lang="en-US" sz="1200" dirty="0">
                         <a:latin typeface="Calibri" charset="0"/>
                         <a:ea typeface="Calibri" charset="0"/>
                         <a:cs typeface="Calibri" charset="0"/>
                       </a:endParaRPr>
-                      <a:r>
-                        <a:rPr lang="en-US" dirty="0"/>
-                        <a:t>3 known bugs undetected in L1</a:t>
-                      </a:r>
                     </a:p>
                   </a:txBody>
                   <a:tcPr anchor="ctr">
@@ -10581,15 +11439,22 @@
                       <a:pPr marL="0" indent="0">
                         <a:buNone/>
                       </a:pPr>
-                      <a:endParaRPr lang="en-US" sz="1200">
+                      <a:r>
+                        <a:rPr lang="en-US" sz="1200" dirty="0">
+                          <a:solidFill>
+                            <a:srgbClr val="1B2227"/>
+                          </a:solidFill>
+                          <a:latin typeface="Calibri" pitchFamily="34" charset="0"/>
+                          <a:ea typeface="Calibri" pitchFamily="34" charset="-122"/>
+                          <a:cs typeface="Calibri" pitchFamily="34" charset="-120"/>
+                        </a:rPr>
+                        <a:t>Hight</a:t>
+                      </a:r>
+                      <a:endParaRPr lang="en-US" sz="1200" dirty="0">
                         <a:latin typeface="Calibri" charset="0"/>
                         <a:ea typeface="Calibri" charset="0"/>
                         <a:cs typeface="Calibri" charset="0"/>
                       </a:endParaRPr>
-                      <a:r>
-                        <a:rPr lang="en-US" dirty="0"/>
-                        <a:t>3/3 caught &amp; fixed autonomously</a:t>
-                      </a:r>
                     </a:p>
                   </a:txBody>
                   <a:tcPr anchor="ctr">
@@ -10642,15 +11507,22 @@
                       <a:pPr marL="0" indent="0">
                         <a:buNone/>
                       </a:pPr>
-                      <a:endParaRPr lang="en-US" sz="1200">
+                      <a:r>
+                        <a:rPr lang="en-US" sz="1200" dirty="0">
+                          <a:solidFill>
+                            <a:srgbClr val="1B2227"/>
+                          </a:solidFill>
+                          <a:latin typeface="Calibri" pitchFamily="34" charset="0"/>
+                          <a:ea typeface="Calibri" pitchFamily="34" charset="-122"/>
+                          <a:cs typeface="Calibri" pitchFamily="34" charset="-120"/>
+                        </a:rPr>
+                        <a:t>Coverage and speed in test scenarios</a:t>
+                      </a:r>
+                      <a:endParaRPr lang="en-US" sz="1200" dirty="0">
                         <a:latin typeface="Calibri" charset="0"/>
                         <a:ea typeface="Calibri" charset="0"/>
                         <a:cs typeface="Calibri" charset="0"/>
                       </a:endParaRPr>
-                      <a:r>
-                        <a:rPr lang="en-US" dirty="0"/>
-                        <a:t>+100% defect detection</a:t>
-                      </a:r>
                     </a:p>
                   </a:txBody>
                   <a:tcPr anchor="ctr">
@@ -10710,15 +11582,22 @@
                       <a:pPr marL="0" indent="0">
                         <a:buNone/>
                       </a:pPr>
-                      <a:endParaRPr lang="en-US" sz="1200">
+                      <a:r>
+                        <a:rPr lang="en-US" sz="1200" dirty="0">
+                          <a:solidFill>
+                            <a:srgbClr val="1B2227"/>
+                          </a:solidFill>
+                          <a:latin typeface="Calibri" pitchFamily="34" charset="0"/>
+                          <a:ea typeface="Calibri" pitchFamily="34" charset="-122"/>
+                          <a:cs typeface="Calibri" pitchFamily="34" charset="-120"/>
+                        </a:rPr>
+                        <a:t>Team benefit</a:t>
+                      </a:r>
+                      <a:endParaRPr lang="en-US" sz="1200" dirty="0">
                         <a:latin typeface="Calibri" charset="0"/>
                         <a:ea typeface="Calibri" charset="0"/>
                         <a:cs typeface="Calibri" charset="0"/>
                       </a:endParaRPr>
-                      <a:r>
-                        <a:rPr lang="en-US" dirty="0"/>
-                        <a:t>Migration frequency / project</a:t>
-                      </a:r>
                     </a:p>
                   </a:txBody>
                   <a:tcPr anchor="ctr">
@@ -10771,15 +11650,22 @@
                       <a:pPr marL="0" indent="0">
                         <a:buNone/>
                       </a:pPr>
+                      <a:r>
+                        <a:rPr lang="en-US" sz="1200">
+                          <a:solidFill>
+                            <a:srgbClr val="1B2227"/>
+                          </a:solidFill>
+                          <a:latin typeface="Calibri" pitchFamily="34" charset="0"/>
+                          <a:ea typeface="Calibri" pitchFamily="34" charset="-122"/>
+                          <a:cs typeface="Calibri" pitchFamily="34" charset="-120"/>
+                        </a:rPr>
+                        <a:t>N/A</a:t>
+                      </a:r>
                       <a:endParaRPr lang="en-US" sz="1200">
                         <a:latin typeface="Calibri" charset="0"/>
                         <a:ea typeface="Calibri" charset="0"/>
                         <a:cs typeface="Calibri" charset="0"/>
                       </a:endParaRPr>
-                      <a:r>
-                        <a:rPr lang="en-US" dirty="0"/>
-                        <a:t>1-2x per year, high manual cost</a:t>
-                      </a:r>
                     </a:p>
                   </a:txBody>
                   <a:tcPr anchor="ctr">
@@ -10832,15 +11718,22 @@
                       <a:pPr marL="0" indent="0">
                         <a:buNone/>
                       </a:pPr>
-                      <a:endParaRPr lang="en-US" sz="1200">
+                      <a:r>
+                        <a:rPr lang="en-US" sz="1200" dirty="0">
+                          <a:solidFill>
+                            <a:srgbClr val="1B2227"/>
+                          </a:solidFill>
+                          <a:latin typeface="Calibri" pitchFamily="34" charset="0"/>
+                          <a:ea typeface="Calibri" pitchFamily="34" charset="-122"/>
+                          <a:cs typeface="Calibri" pitchFamily="34" charset="-120"/>
+                        </a:rPr>
+                        <a:t>3 hours</a:t>
+                      </a:r>
+                      <a:endParaRPr lang="en-US" sz="1200" dirty="0">
                         <a:latin typeface="Calibri" charset="0"/>
                         <a:ea typeface="Calibri" charset="0"/>
                         <a:cs typeface="Calibri" charset="0"/>
                       </a:endParaRPr>
-                      <a:r>
-                        <a:rPr lang="en-US" dirty="0"/>
-                        <a:t>Same frequency, agent absorbs complexity</a:t>
-                      </a:r>
                     </a:p>
                   </a:txBody>
                   <a:tcPr anchor="ctr">
@@ -10893,266 +11786,22 @@
                       <a:pPr marL="0" indent="0">
                         <a:buNone/>
                       </a:pPr>
-                      <a:endParaRPr lang="en-US" sz="1200">
+                      <a:r>
+                        <a:rPr lang="en-US" sz="1200" dirty="0">
+                          <a:solidFill>
+                            <a:srgbClr val="1B2227"/>
+                          </a:solidFill>
+                          <a:latin typeface="Calibri" pitchFamily="34" charset="0"/>
+                          <a:ea typeface="Calibri" pitchFamily="34" charset="-122"/>
+                          <a:cs typeface="Calibri" pitchFamily="34" charset="-120"/>
+                        </a:rPr>
+                        <a:t>Benefit about test regression</a:t>
+                      </a:r>
+                      <a:endParaRPr lang="en-US" sz="1200" dirty="0">
                         <a:latin typeface="Calibri" charset="0"/>
                         <a:ea typeface="Calibri" charset="0"/>
                         <a:cs typeface="Calibri" charset="0"/>
                       </a:endParaRPr>
-                      <a:r>
-                        <a:rPr lang="en-US" dirty="0"/>
-                        <a:t>Risk &amp; cost per run reduced</a:t>
-                      </a:r>
-                    </a:p>
-                  </a:txBody>
-                  <a:tcPr anchor="ctr">
-                    <a:lnL w="6350" cap="flat" cmpd="sng" algn="ctr">
-                      <a:solidFill>
-                        <a:srgbClr val="B7C4CC"/>
-                      </a:solidFill>
-                      <a:prstDash val="solid"/>
-                      <a:round/>
-                      <a:headEnd type="none" w="med" len="med"/>
-                      <a:tailEnd type="none" w="med" len="med"/>
-                    </a:lnL>
-                    <a:lnR w="6350" cap="flat" cmpd="sng" algn="ctr">
-                      <a:solidFill>
-                        <a:srgbClr val="B7C4CC"/>
-                      </a:solidFill>
-                      <a:prstDash val="solid"/>
-                      <a:round/>
-                      <a:headEnd type="none" w="med" len="med"/>
-                      <a:tailEnd type="none" w="med" len="med"/>
-                    </a:lnR>
-                    <a:lnT w="6350" cap="flat" cmpd="sng" algn="ctr">
-                      <a:solidFill>
-                        <a:srgbClr val="B7C4CC"/>
-                      </a:solidFill>
-                      <a:prstDash val="solid"/>
-                      <a:round/>
-                      <a:headEnd type="none" w="med" len="med"/>
-                      <a:tailEnd type="none" w="med" len="med"/>
-                    </a:lnT>
-                    <a:lnB w="6350" cap="flat" cmpd="sng" algn="ctr">
-                      <a:solidFill>
-                        <a:srgbClr val="B7C4CC"/>
-                      </a:solidFill>
-                      <a:prstDash val="solid"/>
-                      <a:round/>
-                      <a:headEnd type="none" w="med" len="med"/>
-                      <a:tailEnd type="none" w="med" len="med"/>
-                    </a:lnB>
-                    <a:solidFill>
-                      <a:srgbClr val="FFFFFF"/>
-                    </a:solidFill>
-                  </a:tcPr>
-                </a:tc>
-                <a:extLst>
-                  <a:ext uri="{0D108BD9-81ED-4DB2-BD59-A6C34878D82A}">
-                    <a16:rowId xmlns:a16="http://schemas.microsoft.com/office/drawing/2014/main" val="10004"/>
-                  </a:ext>
-                </a:extLst>
-              </a:tr>
-              <a:tr h="457200">
-                <a:tc>
-                  <a:txBody>
-                    <a:bodyPr/>
-                    <a:lstStyle/>
-                    <a:p>
-                      <a:pPr marL="0" indent="0">
-                        <a:buNone/>
-                      </a:pPr>
-                      <a:endParaRPr lang="en-US" sz="1200">
-                        <a:latin typeface="Calibri" charset="0"/>
-                        <a:ea typeface="Calibri" charset="0"/>
-                        <a:cs typeface="Calibri" charset="0"/>
-                      </a:endParaRPr>
-                      <a:r>
-                        <a:rPr lang="en-US" dirty="0"/>
-                        <a:t>QA engineers on future migrations</a:t>
-                      </a:r>
-                    </a:p>
-                  </a:txBody>
-                  <a:tcPr anchor="ctr">
-                    <a:lnL w="6350" cap="flat" cmpd="sng" algn="ctr">
-                      <a:solidFill>
-                        <a:srgbClr val="B7C4CC"/>
-                      </a:solidFill>
-                      <a:prstDash val="solid"/>
-                      <a:round/>
-                      <a:headEnd type="none" w="med" len="med"/>
-                      <a:tailEnd type="none" w="med" len="med"/>
-                    </a:lnL>
-                    <a:lnR w="6350" cap="flat" cmpd="sng" algn="ctr">
-                      <a:solidFill>
-                        <a:srgbClr val="B7C4CC"/>
-                      </a:solidFill>
-                      <a:prstDash val="solid"/>
-                      <a:round/>
-                      <a:headEnd type="none" w="med" len="med"/>
-                      <a:tailEnd type="none" w="med" len="med"/>
-                    </a:lnR>
-                    <a:lnT w="6350" cap="flat" cmpd="sng" algn="ctr">
-                      <a:solidFill>
-                        <a:srgbClr val="B7C4CC"/>
-                      </a:solidFill>
-                      <a:prstDash val="solid"/>
-                      <a:round/>
-                      <a:headEnd type="none" w="med" len="med"/>
-                      <a:tailEnd type="none" w="med" len="med"/>
-                    </a:lnT>
-                    <a:lnB w="6350" cap="flat" cmpd="sng" algn="ctr">
-                      <a:solidFill>
-                        <a:srgbClr val="B7C4CC"/>
-                      </a:solidFill>
-                      <a:prstDash val="solid"/>
-                      <a:round/>
-                      <a:headEnd type="none" w="med" len="med"/>
-                      <a:tailEnd type="none" w="med" len="med"/>
-                    </a:lnB>
-                    <a:solidFill>
-                      <a:srgbClr val="FFFFFF"/>
-                    </a:solidFill>
-                  </a:tcPr>
-                </a:tc>
-                <a:tc>
-                  <a:txBody>
-                    <a:bodyPr/>
-                    <a:lstStyle/>
-                    <a:p>
-                      <a:pPr marL="0" indent="0">
-                        <a:buNone/>
-                      </a:pPr>
-                      <a:endParaRPr lang="en-US" sz="1200">
-                        <a:latin typeface="Calibri" charset="0"/>
-                        <a:ea typeface="Calibri" charset="0"/>
-                        <a:cs typeface="Calibri" charset="0"/>
-                      </a:endParaRPr>
-                      <a:r>
-                        <a:rPr lang="en-US" dirty="0"/>
-                        <a:t>N/A (no reusable baseline)</a:t>
-                      </a:r>
-                    </a:p>
-                  </a:txBody>
-                  <a:tcPr anchor="ctr">
-                    <a:lnL w="6350" cap="flat" cmpd="sng" algn="ctr">
-                      <a:solidFill>
-                        <a:srgbClr val="B7C4CC"/>
-                      </a:solidFill>
-                      <a:prstDash val="solid"/>
-                      <a:round/>
-                      <a:headEnd type="none" w="med" len="med"/>
-                      <a:tailEnd type="none" w="med" len="med"/>
-                    </a:lnL>
-                    <a:lnR w="6350" cap="flat" cmpd="sng" algn="ctr">
-                      <a:solidFill>
-                        <a:srgbClr val="B7C4CC"/>
-                      </a:solidFill>
-                      <a:prstDash val="solid"/>
-                      <a:round/>
-                      <a:headEnd type="none" w="med" len="med"/>
-                      <a:tailEnd type="none" w="med" len="med"/>
-                    </a:lnR>
-                    <a:lnT w="6350" cap="flat" cmpd="sng" algn="ctr">
-                      <a:solidFill>
-                        <a:srgbClr val="B7C4CC"/>
-                      </a:solidFill>
-                      <a:prstDash val="solid"/>
-                      <a:round/>
-                      <a:headEnd type="none" w="med" len="med"/>
-                      <a:tailEnd type="none" w="med" len="med"/>
-                    </a:lnT>
-                    <a:lnB w="6350" cap="flat" cmpd="sng" algn="ctr">
-                      <a:solidFill>
-                        <a:srgbClr val="B7C4CC"/>
-                      </a:solidFill>
-                      <a:prstDash val="solid"/>
-                      <a:round/>
-                      <a:headEnd type="none" w="med" len="med"/>
-                      <a:tailEnd type="none" w="med" len="med"/>
-                    </a:lnB>
-                    <a:solidFill>
-                      <a:srgbClr val="FFFFFF"/>
-                    </a:solidFill>
-                  </a:tcPr>
-                </a:tc>
-                <a:tc>
-                  <a:txBody>
-                    <a:bodyPr/>
-                    <a:lstStyle/>
-                    <a:p>
-                      <a:pPr marL="0" indent="0">
-                        <a:buNone/>
-                      </a:pPr>
-                      <a:endParaRPr lang="en-US" sz="1200">
-                        <a:latin typeface="Calibri" charset="0"/>
-                        <a:ea typeface="Calibri" charset="0"/>
-                        <a:cs typeface="Calibri" charset="0"/>
-                      </a:endParaRPr>
-                      <a:r>
-                        <a:rPr lang="en-US" dirty="0"/>
-                        <a:t>Any team with Claude Code + MCP</a:t>
-                      </a:r>
-                    </a:p>
-                  </a:txBody>
-                  <a:tcPr anchor="ctr">
-                    <a:lnL w="6350" cap="flat" cmpd="sng" algn="ctr">
-                      <a:solidFill>
-                        <a:srgbClr val="B7C4CC"/>
-                      </a:solidFill>
-                      <a:prstDash val="solid"/>
-                      <a:round/>
-                      <a:headEnd type="none" w="med" len="med"/>
-                      <a:tailEnd type="none" w="med" len="med"/>
-                    </a:lnL>
-                    <a:lnR w="6350" cap="flat" cmpd="sng" algn="ctr">
-                      <a:solidFill>
-                        <a:srgbClr val="B7C4CC"/>
-                      </a:solidFill>
-                      <a:prstDash val="solid"/>
-                      <a:round/>
-                      <a:headEnd type="none" w="med" len="med"/>
-                      <a:tailEnd type="none" w="med" len="med"/>
-                    </a:lnR>
-                    <a:lnT w="6350" cap="flat" cmpd="sng" algn="ctr">
-                      <a:solidFill>
-                        <a:srgbClr val="B7C4CC"/>
-                      </a:solidFill>
-                      <a:prstDash val="solid"/>
-                      <a:round/>
-                      <a:headEnd type="none" w="med" len="med"/>
-                      <a:tailEnd type="none" w="med" len="med"/>
-                    </a:lnT>
-                    <a:lnB w="6350" cap="flat" cmpd="sng" algn="ctr">
-                      <a:solidFill>
-                        <a:srgbClr val="B7C4CC"/>
-                      </a:solidFill>
-                      <a:prstDash val="solid"/>
-                      <a:round/>
-                      <a:headEnd type="none" w="med" len="med"/>
-                      <a:tailEnd type="none" w="med" len="med"/>
-                    </a:lnB>
-                    <a:solidFill>
-                      <a:srgbClr val="FFFFFF"/>
-                    </a:solidFill>
-                  </a:tcPr>
-                </a:tc>
-                <a:tc>
-                  <a:txBody>
-                    <a:bodyPr/>
-                    <a:lstStyle/>
-                    <a:p>
-                      <a:pPr marL="0" indent="0">
-                        <a:buNone/>
-                      </a:pPr>
-                      <a:endParaRPr lang="en-US" sz="1200">
-                        <a:latin typeface="Calibri" charset="0"/>
-                        <a:ea typeface="Calibri" charset="0"/>
-                        <a:cs typeface="Calibri" charset="0"/>
-                      </a:endParaRPr>
-                      <a:r>
-                        <a:rPr lang="en-US" dirty="0"/>
-                        <a:t>~12-20 h saved per migration</a:t>
-                      </a:r>
                     </a:p>
                   </a:txBody>
                   <a:tcPr anchor="ctr">
@@ -11262,14 +11911,16 @@
           <a:bodyPr wrap="square" rtlCol="0" anchor="ctr"/>
           <a:lstStyle/>
           <a:p>
+            <a:r>
+              <a:rPr lang="en-US" sz="1100" dirty="0"/>
+              <a:t>Agent-driven migration reduced the Cypress-to-Playwright turnaround from 2-3 days to 3.5 hours (75% time reduction). All 3 failure modes caught and fixed within the same session. The agent definition, prompts, and CLAUDE.md are reusable across future migrations.</a:t>
+            </a:r>
+          </a:p>
+          <a:p>
             <a:pPr marL="0" indent="0" algn="l">
               <a:buNone/>
             </a:pPr>
-            <a:endParaRPr lang="en-US" sz="1100"/>
-            <a:r>
-              <a:rPr lang="en-US" dirty="0"/>
-              <a:t>Agent-driven migration reduced the Cypress-to-Playwright turnaround from 2-3 days to 3.5 hours (75% time reduction). All 3 failure modes caught and fixed within the same session. The agent definition, prompts, and CLAUDE.md are reusable across future migrations.</a:t>
-            </a:r>
+            <a:endParaRPr lang="en-US" sz="1100" dirty="0"/>
           </a:p>
         </p:txBody>
       </p:sp>
@@ -11489,10 +12140,6 @@
               <a:buNone/>
             </a:pPr>
             <a:endParaRPr lang="en-US" sz="1400"/>
-            <a:r>
-              <a:rPr lang="en-US" dirty="0"/>
-              <a:t>What is reusable?</a:t>
-            </a:r>
           </a:p>
         </p:txBody>
       </p:sp>
@@ -11504,7 +12151,7 @@
         </p:nvSpPr>
         <p:spPr>
           <a:xfrm>
-            <a:off x="640080" y="1709928"/>
+            <a:off x="891540" y="1581894"/>
             <a:ext cx="3611880" cy="777240"/>
           </a:xfrm>
           <a:prstGeom prst="rect">
@@ -11520,9 +12167,11 @@
             <a:pPr marL="0" indent="0">
               <a:buNone/>
             </a:pPr>
-            <a:endParaRPr lang="en-US" sz="1150"/>
-            <a:r>
-              <a:rPr lang="en-US" dirty="0"/>
+            <a:r>
+              <a:rPr lang="en-US" sz="1200" dirty="0">
+                <a:latin typeface="Arial" panose="020B0604020202020204" pitchFamily="34" charset="0"/>
+                <a:cs typeface="Arial" panose="020B0604020202020204" pitchFamily="34" charset="0"/>
+              </a:rPr>
               <a:t>.claude/agents/playwright-migration.md (agent definition with tool loop, human gate, and failure handling), CLAUDE.md convention layer, versioned prompts under prompts/, full project structure with POM scaffold.</a:t>
             </a:r>
           </a:p>
@@ -11648,10 +12297,6 @@
               <a:buNone/>
             </a:pPr>
             <a:endParaRPr lang="en-US" sz="1400"/>
-            <a:r>
-              <a:rPr lang="en-US" dirty="0"/>
-              <a:t>Who can adopt it?</a:t>
-            </a:r>
           </a:p>
         </p:txBody>
       </p:sp>
@@ -11679,10 +12324,12 @@
             <a:pPr marL="0" indent="0">
               <a:buNone/>
             </a:pPr>
-            <a:endParaRPr lang="en-US" sz="1150"/>
-            <a:r>
-              <a:rPr lang="en-US" dirty="0"/>
-              <a:t>QA engineers on any Cypress-to-Playwright migration. Any team with Claude Code access and MCP Playwright. Works with any web app the agent can navigate — not OrangeHRM-specific.</a:t>
+            <a:r>
+              <a:rPr lang="en-US" sz="1200" dirty="0">
+                <a:latin typeface="Arial" panose="020B0604020202020204" pitchFamily="34" charset="0"/>
+                <a:cs typeface="Arial" panose="020B0604020202020204" pitchFamily="34" charset="0"/>
+              </a:rPr>
+              <a:t>QA engineers on any Cypress-to-Playwright migration. Any team with Claude Code access and MCP Playwright. Works with any web app the agent can navigate - not OrangeHRM-specific.</a:t>
             </a:r>
           </a:p>
         </p:txBody>
@@ -11696,7 +12343,7 @@
         <p:spPr>
           <a:xfrm>
             <a:off x="457200" y="2788920"/>
-            <a:ext cx="3977640" cy="1417320"/>
+            <a:ext cx="3977640" cy="1660680"/>
           </a:xfrm>
           <a:prstGeom prst="roundRect">
             <a:avLst>
@@ -11807,10 +12454,6 @@
               <a:buNone/>
             </a:pPr>
             <a:endParaRPr lang="en-US" sz="1400"/>
-            <a:r>
-              <a:rPr lang="en-US" dirty="0"/>
-              <a:t>What was packaged?</a:t>
-            </a:r>
           </a:p>
         </p:txBody>
       </p:sp>
@@ -11822,7 +12465,7 @@
         </p:nvSpPr>
         <p:spPr>
           <a:xfrm>
-            <a:off x="640080" y="3355848"/>
+            <a:off x="891540" y="3209508"/>
             <a:ext cx="3611880" cy="777240"/>
           </a:xfrm>
           <a:prstGeom prst="rect">
@@ -11838,10 +12481,35 @@
             <a:pPr marL="0" indent="0">
               <a:buNone/>
             </a:pPr>
-            <a:endParaRPr lang="en-US" sz="1150"/>
-            <a:r>
-              <a:rPr lang="en-US" dirty="0"/>
-              <a:t>Git repo (feature/migration-progress): CLAUDE.md, agent definition, prompts/, reports/ (HTML evidence), docs/ (architecture + evaluation), README with step-by-step replication instructions.</a:t>
+            <a:r>
+              <a:rPr lang="en-US" sz="1200" dirty="0">
+                <a:solidFill>
+                  <a:srgbClr val="1B2227"/>
+                </a:solidFill>
+                <a:latin typeface="Arial" panose="020B0604020202020204" pitchFamily="34" charset="0"/>
+                <a:cs typeface="Arial" panose="020B0604020202020204" pitchFamily="34" charset="0"/>
+              </a:rPr>
+              <a:t>Git repo branch L2 (public): CLAUDE.md, agent definition (.</a:t>
+            </a:r>
+            <a:r>
+              <a:rPr lang="en-US" sz="1200" dirty="0" err="1">
+                <a:solidFill>
+                  <a:srgbClr val="1B2227"/>
+                </a:solidFill>
+                <a:latin typeface="Arial" panose="020B0604020202020204" pitchFamily="34" charset="0"/>
+                <a:cs typeface="Arial" panose="020B0604020202020204" pitchFamily="34" charset="0"/>
+              </a:rPr>
+              <a:t>claude</a:t>
+            </a:r>
+            <a:r>
+              <a:rPr lang="en-US" sz="1200" dirty="0">
+                <a:solidFill>
+                  <a:srgbClr val="1B2227"/>
+                </a:solidFill>
+                <a:latin typeface="Arial" panose="020B0604020202020204" pitchFamily="34" charset="0"/>
+                <a:cs typeface="Arial" panose="020B0604020202020204" pitchFamily="34" charset="0"/>
+              </a:rPr>
+              <a:t>/agents/playwright-migration.md), prompts/, reports/ (HTML evidence), docs/ (architecture, evaluation, stack, reflection). Clone and run - no config beyond .env credentials.</a:t>
             </a:r>
           </a:p>
         </p:txBody>
@@ -11855,7 +12523,7 @@
         <p:spPr>
           <a:xfrm>
             <a:off x="4709160" y="2788920"/>
-            <a:ext cx="3977640" cy="1417320"/>
+            <a:ext cx="3977640" cy="1660680"/>
           </a:xfrm>
           <a:prstGeom prst="roundRect">
             <a:avLst>
@@ -11966,10 +12634,6 @@
               <a:buNone/>
             </a:pPr>
             <a:endParaRPr lang="en-US" sz="1400"/>
-            <a:r>
-              <a:rPr lang="en-US" dirty="0"/>
-              <a:t>Org-scale potential</a:t>
-            </a:r>
           </a:p>
         </p:txBody>
       </p:sp>
@@ -11997,11 +12661,193 @@
             <a:pPr marL="0" indent="0">
               <a:buNone/>
             </a:pPr>
-            <a:endParaRPr lang="en-US" sz="1150"/>
-            <a:r>
-              <a:rPr lang="en-US" dirty="0"/>
-              <a:t>10x reduction in migration effort per suite. Consistent POM structure across all generated code. Next engagement starts from a working baseline — cumulative improvement as CLAUDE.md grows with each project.</a:t>
-            </a:r>
+            <a:r>
+              <a:rPr lang="en-US" sz="1200" dirty="0">
+                <a:latin typeface="Arial" panose="020B0604020202020204" pitchFamily="34" charset="0"/>
+                <a:cs typeface="Arial" panose="020B0604020202020204" pitchFamily="34" charset="0"/>
+              </a:rPr>
+              <a:t>10x reduction in migration effort per suite. Consistent POM structure across all generated code. Next engagement starts from a working baseline.</a:t>
+            </a:r>
+          </a:p>
+        </p:txBody>
+      </p:sp>
+      <p:sp>
+        <p:nvSpPr>
+          <p:cNvPr id="27" name="Text 4">
+            <a:extLst>
+              <a:ext uri="{FF2B5EF4-FFF2-40B4-BE49-F238E27FC236}">
+                <a16:creationId xmlns:a16="http://schemas.microsoft.com/office/drawing/2014/main" id="{F90BBA75-8454-8315-E893-B2ECB3958D05}"/>
+              </a:ext>
+            </a:extLst>
+          </p:cNvPr>
+          <p:cNvSpPr/>
+          <p:nvPr/>
+        </p:nvSpPr>
+        <p:spPr>
+          <a:xfrm>
+            <a:off x="1165860" y="1257300"/>
+            <a:ext cx="3200400" cy="365760"/>
+          </a:xfrm>
+          <a:prstGeom prst="rect">
+            <a:avLst/>
+          </a:prstGeom>
+          <a:noFill/>
+          <a:ln/>
+        </p:spPr>
+        <p:txBody>
+          <a:bodyPr wrap="square" rtlCol="0" anchor="ctr"/>
+          <a:lstStyle/>
+          <a:p>
+            <a:pPr marL="0" indent="0">
+              <a:buNone/>
+            </a:pPr>
+            <a:r>
+              <a:rPr lang="en-US" sz="1400" b="1" dirty="0">
+                <a:solidFill>
+                  <a:srgbClr val="024879"/>
+                </a:solidFill>
+                <a:latin typeface="Arial" pitchFamily="34" charset="0"/>
+                <a:ea typeface="Arial" pitchFamily="34" charset="-122"/>
+                <a:cs typeface="Arial" pitchFamily="34" charset="-120"/>
+              </a:rPr>
+              <a:t>What is reusable?</a:t>
+            </a:r>
+            <a:endParaRPr lang="en-US" sz="1400" dirty="0"/>
+          </a:p>
+        </p:txBody>
+      </p:sp>
+      <p:sp>
+        <p:nvSpPr>
+          <p:cNvPr id="29" name="Text 9">
+            <a:extLst>
+              <a:ext uri="{FF2B5EF4-FFF2-40B4-BE49-F238E27FC236}">
+                <a16:creationId xmlns:a16="http://schemas.microsoft.com/office/drawing/2014/main" id="{BFB8C2AC-E9F1-DC2F-777B-24F7F38A9D42}"/>
+              </a:ext>
+            </a:extLst>
+          </p:cNvPr>
+          <p:cNvSpPr/>
+          <p:nvPr/>
+        </p:nvSpPr>
+        <p:spPr>
+          <a:xfrm>
+            <a:off x="5349240" y="1296948"/>
+            <a:ext cx="3200400" cy="365760"/>
+          </a:xfrm>
+          <a:prstGeom prst="rect">
+            <a:avLst/>
+          </a:prstGeom>
+          <a:noFill/>
+          <a:ln/>
+        </p:spPr>
+        <p:txBody>
+          <a:bodyPr wrap="square" rtlCol="0" anchor="ctr"/>
+          <a:lstStyle/>
+          <a:p>
+            <a:pPr marL="0" indent="0">
+              <a:buNone/>
+            </a:pPr>
+            <a:r>
+              <a:rPr lang="en-US" sz="1400" b="1" dirty="0">
+                <a:solidFill>
+                  <a:srgbClr val="024879"/>
+                </a:solidFill>
+                <a:latin typeface="Arial" pitchFamily="34" charset="0"/>
+                <a:ea typeface="Arial" pitchFamily="34" charset="-122"/>
+                <a:cs typeface="Arial" pitchFamily="34" charset="-120"/>
+              </a:rPr>
+              <a:t>Who can adopt it?</a:t>
+            </a:r>
+            <a:endParaRPr lang="en-US" sz="1400" dirty="0"/>
+          </a:p>
+        </p:txBody>
+      </p:sp>
+      <p:sp>
+        <p:nvSpPr>
+          <p:cNvPr id="31" name="Text 14">
+            <a:extLst>
+              <a:ext uri="{FF2B5EF4-FFF2-40B4-BE49-F238E27FC236}">
+                <a16:creationId xmlns:a16="http://schemas.microsoft.com/office/drawing/2014/main" id="{84F8E539-C081-2F59-6F03-355457563D0B}"/>
+              </a:ext>
+            </a:extLst>
+          </p:cNvPr>
+          <p:cNvSpPr/>
+          <p:nvPr/>
+        </p:nvSpPr>
+        <p:spPr>
+          <a:xfrm>
+            <a:off x="1097280" y="2926080"/>
+            <a:ext cx="3200400" cy="365760"/>
+          </a:xfrm>
+          <a:prstGeom prst="rect">
+            <a:avLst/>
+          </a:prstGeom>
+          <a:noFill/>
+          <a:ln/>
+        </p:spPr>
+        <p:txBody>
+          <a:bodyPr wrap="square" rtlCol="0" anchor="ctr"/>
+          <a:lstStyle/>
+          <a:p>
+            <a:pPr marL="0" indent="0">
+              <a:buNone/>
+            </a:pPr>
+            <a:r>
+              <a:rPr lang="en-US" sz="1400" b="1" dirty="0">
+                <a:solidFill>
+                  <a:srgbClr val="024879"/>
+                </a:solidFill>
+                <a:latin typeface="Arial" pitchFamily="34" charset="0"/>
+                <a:ea typeface="Arial" pitchFamily="34" charset="-122"/>
+                <a:cs typeface="Arial" pitchFamily="34" charset="-120"/>
+              </a:rPr>
+              <a:t>What did you package?</a:t>
+            </a:r>
+            <a:endParaRPr lang="en-US" sz="1400" dirty="0"/>
+          </a:p>
+        </p:txBody>
+      </p:sp>
+      <p:sp>
+        <p:nvSpPr>
+          <p:cNvPr id="33" name="Text 19">
+            <a:extLst>
+              <a:ext uri="{FF2B5EF4-FFF2-40B4-BE49-F238E27FC236}">
+                <a16:creationId xmlns:a16="http://schemas.microsoft.com/office/drawing/2014/main" id="{D5E21393-87F7-D961-4A4D-FF496883E613}"/>
+              </a:ext>
+            </a:extLst>
+          </p:cNvPr>
+          <p:cNvSpPr/>
+          <p:nvPr/>
+        </p:nvSpPr>
+        <p:spPr>
+          <a:xfrm>
+            <a:off x="5349240" y="2926080"/>
+            <a:ext cx="3200400" cy="365760"/>
+          </a:xfrm>
+          <a:prstGeom prst="rect">
+            <a:avLst/>
+          </a:prstGeom>
+          <a:noFill/>
+          <a:ln/>
+        </p:spPr>
+        <p:txBody>
+          <a:bodyPr wrap="square" rtlCol="0" anchor="ctr"/>
+          <a:lstStyle/>
+          <a:p>
+            <a:pPr marL="0" indent="0">
+              <a:buNone/>
+            </a:pPr>
+            <a:r>
+              <a:rPr lang="en-US" sz="1400" b="1" dirty="0">
+                <a:solidFill>
+                  <a:srgbClr val="024879"/>
+                </a:solidFill>
+                <a:latin typeface="Arial" pitchFamily="34" charset="0"/>
+                <a:ea typeface="Arial" pitchFamily="34" charset="-122"/>
+                <a:cs typeface="Arial" pitchFamily="34" charset="-120"/>
+              </a:rPr>
+              <a:t>Org-scale potential</a:t>
+            </a:r>
+            <a:endParaRPr lang="en-US" sz="1400" dirty="0"/>
           </a:p>
         </p:txBody>
       </p:sp>
@@ -12063,7 +12909,7 @@
               <a:buNone/>
             </a:pPr>
             <a:r>
-              <a:rPr lang="en-US" sz="2600" b="1">
+              <a:rPr lang="en-US" sz="2600" b="1" dirty="0">
                 <a:solidFill>
                   <a:srgbClr val="024879"/>
                 </a:solidFill>
@@ -12073,7 +12919,7 @@
               </a:rPr>
               <a:t>What AI Got Right &amp; What It Got Wrong</a:t>
             </a:r>
-            <a:endParaRPr lang="en-US" sz="2600"/>
+            <a:endParaRPr lang="en-US" sz="2600" dirty="0"/>
           </a:p>
         </p:txBody>
       </p:sp>
@@ -12182,10 +13028,6 @@
               <a:buNone/>
             </a:pPr>
             <a:endParaRPr lang="en-US" sz="1400"/>
-            <a:r>
-              <a:rPr lang="en-US" dirty="0"/>
-              <a:t>What AI got RIGHT</a:t>
-            </a:r>
           </a:p>
         </p:txBody>
       </p:sp>
@@ -12197,7 +13039,7 @@
         </p:nvSpPr>
         <p:spPr>
           <a:xfrm>
-            <a:off x="1188720" y="1600200"/>
+            <a:off x="1188720" y="1527048"/>
             <a:ext cx="7223760" cy="548640"/>
           </a:xfrm>
           <a:prstGeom prst="rect">
@@ -12214,10 +13056,12 @@
               <a:buSzPct val="100000"/>
               <a:buChar char="•"/>
             </a:pPr>
-            <a:endParaRPr lang="en-US" sz="1150"/>
-            <a:r>
-              <a:rPr lang="en-US" dirty="0"/>
-              <a:t>Selector generation — mapped all 7 OrangeHRM requirements to working DOM selectors via live MCP navigation; zero manual DevTools inspection required.</a:t>
+            <a:r>
+              <a:rPr lang="en-US" sz="1200" dirty="0">
+                <a:latin typeface="Arial" panose="020B0604020202020204" pitchFamily="34" charset="0"/>
+                <a:cs typeface="Arial" panose="020B0604020202020204" pitchFamily="34" charset="0"/>
+              </a:rPr>
+              <a:t>Selector generation - mapped all 7 OrangeHRM requirements to working DOM selectors via live MCP navigation; zero manual DevTools inspection required.</a:t>
             </a:r>
           </a:p>
           <a:p>
@@ -12225,10 +13069,12 @@
               <a:buSzPct val="100000"/>
               <a:buChar char="•"/>
             </a:pPr>
-            <a:endParaRPr lang="en-US" sz="1150"/>
-            <a:r>
-              <a:rPr lang="en-US" dirty="0"/>
-              <a:t>End-to-end code generation — Gherkin, POM classes, and step definitions all correct on first pass for 6 of 8 test scenarios.</a:t>
+            <a:r>
+              <a:rPr lang="en-US" sz="1200" dirty="0">
+                <a:latin typeface="Arial" panose="020B0604020202020204" pitchFamily="34" charset="0"/>
+                <a:cs typeface="Arial" panose="020B0604020202020204" pitchFamily="34" charset="0"/>
+              </a:rPr>
+              <a:t>End-to-end code generation - Gherkin, POM classes, and step definitions all correct on first pass for 6 of 8 test scenarios.</a:t>
             </a:r>
           </a:p>
         </p:txBody>
@@ -12314,10 +13160,6 @@
               <a:buNone/>
             </a:pPr>
             <a:endParaRPr lang="en-US" sz="1400"/>
-            <a:r>
-              <a:rPr lang="en-US" dirty="0"/>
-              <a:t>What AI got WRONG</a:t>
-            </a:r>
           </a:p>
         </p:txBody>
       </p:sp>
@@ -12346,10 +13188,12 @@
               <a:buSzPct val="100000"/>
               <a:buChar char="•"/>
             </a:pPr>
-            <a:endParaRPr lang="en-US" sz="1150"/>
-            <a:r>
-              <a:rPr lang="en-US" dirty="0"/>
-              <a:t>OR-condition masking — clickSave() accepted /pim/addEmployee as success when Employee ID conflicted; silent failure cascaded to 7 downstream tests.</a:t>
+            <a:r>
+              <a:rPr lang="en-US" sz="1200" dirty="0">
+                <a:latin typeface="Arial" panose="020B0604020202020204" pitchFamily="34" charset="0"/>
+                <a:cs typeface="Arial" panose="020B0604020202020204" pitchFamily="34" charset="0"/>
+              </a:rPr>
+              <a:t>OR-condition masking - clickSave() accepted /pim/addEmployee as success when Employee ID conflicted; silent failure cascaded to 7 downstream tests.</a:t>
             </a:r>
           </a:p>
           <a:p>
@@ -12357,10 +13201,12 @@
               <a:buSzPct val="100000"/>
               <a:buChar char="•"/>
             </a:pPr>
-            <a:endParaRPr lang="en-US" sz="1150"/>
-            <a:r>
-              <a:rPr lang="en-US" dirty="0"/>
-              <a:t>Vue timing race — networkidle resolved ~400 ms before Vue rendered error messages; all_text_contents() returned [] masking the real failure reason.</a:t>
+            <a:r>
+              <a:rPr lang="en-US" sz="1200" dirty="0">
+                <a:latin typeface="Arial" panose="020B0604020202020204" pitchFamily="34" charset="0"/>
+                <a:cs typeface="Arial" panose="020B0604020202020204" pitchFamily="34" charset="0"/>
+              </a:rPr>
+              <a:t>Vue timing race - networkidle resolved ~400 ms before Vue rendered error messages; </a:t>
             </a:r>
           </a:p>
         </p:txBody>
@@ -12374,7 +13220,7 @@
         <p:spPr>
           <a:xfrm>
             <a:off x="457200" y="3557016"/>
-            <a:ext cx="8229600" cy="1051560"/>
+            <a:ext cx="8229600" cy="1238184"/>
           </a:xfrm>
           <a:prstGeom prst="roundRect">
             <a:avLst>
@@ -12446,10 +13292,6 @@
               <a:buNone/>
             </a:pPr>
             <a:endParaRPr lang="en-US" sz="1400"/>
-            <a:r>
-              <a:rPr lang="en-US" dirty="0"/>
-              <a:t>What I corrected</a:t>
-            </a:r>
           </a:p>
         </p:txBody>
       </p:sp>
@@ -12461,7 +13303,7 @@
         </p:nvSpPr>
         <p:spPr>
           <a:xfrm>
-            <a:off x="1188720" y="4014216"/>
+            <a:off x="1197864" y="4014216"/>
             <a:ext cx="7223760" cy="548640"/>
           </a:xfrm>
           <a:prstGeom prst="rect">
@@ -12478,9 +13320,11 @@
               <a:buSzPct val="100000"/>
               <a:buChar char="•"/>
             </a:pPr>
-            <a:endParaRPr lang="en-US" sz="1150"/>
-            <a:r>
-              <a:rPr lang="en-US" dirty="0"/>
+            <a:r>
+              <a:rPr lang="en-US" sz="1200" dirty="0">
+                <a:latin typeface="Arial" panose="020B0604020202020204" pitchFamily="34" charset="0"/>
+                <a:cs typeface="Arial" panose="020B0604020202020204" pitchFamily="34" charset="0"/>
+              </a:rPr>
               <a:t>ID collision: removed OR condition; injected explicit NEW_EMP_ID from .env; added strict empNumber/ URL assertion.</a:t>
             </a:r>
           </a:p>
@@ -12489,11 +13333,148 @@
               <a:buSzPct val="100000"/>
               <a:buChar char="•"/>
             </a:pPr>
-            <a:endParaRPr lang="en-US" sz="1150"/>
-            <a:r>
-              <a:rPr lang="en-US" dirty="0"/>
+            <a:r>
+              <a:rPr lang="en-US" sz="1200" dirty="0">
+                <a:latin typeface="Arial" panose="020B0604020202020204" pitchFamily="34" charset="0"/>
+                <a:cs typeface="Arial" panose="020B0604020202020204" pitchFamily="34" charset="0"/>
+              </a:rPr>
               <a:t>Vue timing: replaced networkidle with wait_for_function() polling both success redirect URL and error DOM element simultaneously.</a:t>
             </a:r>
+          </a:p>
+        </p:txBody>
+      </p:sp>
+      <p:sp>
+        <p:nvSpPr>
+          <p:cNvPr id="17" name="Text 3">
+            <a:extLst>
+              <a:ext uri="{FF2B5EF4-FFF2-40B4-BE49-F238E27FC236}">
+                <a16:creationId xmlns:a16="http://schemas.microsoft.com/office/drawing/2014/main" id="{1C775D5B-A040-4AAA-29F9-5D27E71B64DD}"/>
+              </a:ext>
+            </a:extLst>
+          </p:cNvPr>
+          <p:cNvSpPr/>
+          <p:nvPr/>
+        </p:nvSpPr>
+        <p:spPr>
+          <a:xfrm>
+            <a:off x="1280160" y="1132920"/>
+            <a:ext cx="7315200" cy="365760"/>
+          </a:xfrm>
+          <a:prstGeom prst="rect">
+            <a:avLst/>
+          </a:prstGeom>
+          <a:noFill/>
+          <a:ln/>
+        </p:spPr>
+        <p:txBody>
+          <a:bodyPr wrap="square" rtlCol="0" anchor="ctr"/>
+          <a:lstStyle/>
+          <a:p>
+            <a:pPr marL="0" indent="0">
+              <a:buNone/>
+            </a:pPr>
+            <a:r>
+              <a:rPr lang="en-US" sz="1400" b="1" dirty="0">
+                <a:solidFill>
+                  <a:srgbClr val="075056"/>
+                </a:solidFill>
+                <a:latin typeface="Arial" pitchFamily="34" charset="0"/>
+                <a:ea typeface="Arial" pitchFamily="34" charset="-122"/>
+                <a:cs typeface="Arial" pitchFamily="34" charset="-120"/>
+              </a:rPr>
+              <a:t>What AI got RIGHT</a:t>
+            </a:r>
+            <a:endParaRPr lang="en-US" sz="1400" dirty="0"/>
+          </a:p>
+        </p:txBody>
+      </p:sp>
+      <p:sp>
+        <p:nvSpPr>
+          <p:cNvPr id="19" name="Text 7">
+            <a:extLst>
+              <a:ext uri="{FF2B5EF4-FFF2-40B4-BE49-F238E27FC236}">
+                <a16:creationId xmlns:a16="http://schemas.microsoft.com/office/drawing/2014/main" id="{07E86B07-8471-37F4-F682-F29D68AC6241}"/>
+              </a:ext>
+            </a:extLst>
+          </p:cNvPr>
+          <p:cNvSpPr/>
+          <p:nvPr/>
+        </p:nvSpPr>
+        <p:spPr>
+          <a:xfrm>
+            <a:off x="1280160" y="2392128"/>
+            <a:ext cx="7315200" cy="365760"/>
+          </a:xfrm>
+          <a:prstGeom prst="rect">
+            <a:avLst/>
+          </a:prstGeom>
+          <a:noFill/>
+          <a:ln/>
+        </p:spPr>
+        <p:txBody>
+          <a:bodyPr wrap="square" rtlCol="0" anchor="ctr"/>
+          <a:lstStyle/>
+          <a:p>
+            <a:pPr marL="0" indent="0">
+              <a:buNone/>
+            </a:pPr>
+            <a:r>
+              <a:rPr lang="en-US" sz="1400" b="1">
+                <a:solidFill>
+                  <a:srgbClr val="FE3A39"/>
+                </a:solidFill>
+                <a:latin typeface="Arial" pitchFamily="34" charset="0"/>
+                <a:ea typeface="Arial" pitchFamily="34" charset="-122"/>
+                <a:cs typeface="Arial" pitchFamily="34" charset="-120"/>
+              </a:rPr>
+              <a:t>What AI got WRONG</a:t>
+            </a:r>
+            <a:endParaRPr lang="en-US" sz="1400"/>
+          </a:p>
+        </p:txBody>
+      </p:sp>
+      <p:sp>
+        <p:nvSpPr>
+          <p:cNvPr id="21" name="Text 11">
+            <a:extLst>
+              <a:ext uri="{FF2B5EF4-FFF2-40B4-BE49-F238E27FC236}">
+                <a16:creationId xmlns:a16="http://schemas.microsoft.com/office/drawing/2014/main" id="{7A76D905-4019-0331-FD27-D6726957C10C}"/>
+              </a:ext>
+            </a:extLst>
+          </p:cNvPr>
+          <p:cNvSpPr/>
+          <p:nvPr/>
+        </p:nvSpPr>
+        <p:spPr>
+          <a:xfrm>
+            <a:off x="1280160" y="3599136"/>
+            <a:ext cx="7315200" cy="365760"/>
+          </a:xfrm>
+          <a:prstGeom prst="rect">
+            <a:avLst/>
+          </a:prstGeom>
+          <a:noFill/>
+          <a:ln/>
+        </p:spPr>
+        <p:txBody>
+          <a:bodyPr wrap="square" rtlCol="0" anchor="ctr"/>
+          <a:lstStyle/>
+          <a:p>
+            <a:pPr marL="0" indent="0">
+              <a:buNone/>
+            </a:pPr>
+            <a:r>
+              <a:rPr lang="en-US" sz="1400" b="1">
+                <a:solidFill>
+                  <a:srgbClr val="024879"/>
+                </a:solidFill>
+                <a:latin typeface="Arial" pitchFamily="34" charset="0"/>
+                <a:ea typeface="Arial" pitchFamily="34" charset="-122"/>
+                <a:cs typeface="Arial" pitchFamily="34" charset="-120"/>
+              </a:rPr>
+              <a:t>What I corrected manually</a:t>
+            </a:r>
+            <a:endParaRPr lang="en-US" sz="1400"/>
           </a:p>
         </p:txBody>
       </p:sp>
@@ -12555,7 +13536,7 @@
               <a:buNone/>
             </a:pPr>
             <a:r>
-              <a:rPr lang="en-US" sz="2600" b="1">
+              <a:rPr lang="en-US" sz="2600" b="1" dirty="0">
                 <a:solidFill>
                   <a:srgbClr val="024879"/>
                 </a:solidFill>
@@ -12565,7 +13546,7 @@
               </a:rPr>
               <a:t>Evidence &amp; Artifacts</a:t>
             </a:r>
-            <a:endParaRPr lang="en-US" sz="2600"/>
+            <a:endParaRPr lang="en-US" sz="2600" dirty="0"/>
           </a:p>
         </p:txBody>
       </p:sp>
@@ -12679,8 +13660,8 @@
         </p:nvSpPr>
         <p:spPr>
           <a:xfrm>
-            <a:off x="2423160" y="1417320"/>
-            <a:ext cx="2103120" cy="411480"/>
+            <a:off x="1908000" y="1417320"/>
+            <a:ext cx="2618280" cy="777240"/>
           </a:xfrm>
           <a:prstGeom prst="roundRect">
             <a:avLst>
@@ -12713,8 +13694,8 @@
         </p:nvSpPr>
         <p:spPr>
           <a:xfrm>
-            <a:off x="2532888" y="1417320"/>
-            <a:ext cx="1883664" cy="411480"/>
+            <a:off x="1953720" y="1597860"/>
+            <a:ext cx="2471976" cy="411480"/>
           </a:xfrm>
           <a:prstGeom prst="rect">
             <a:avLst/>
@@ -12726,23 +13707,35 @@
           <a:bodyPr wrap="square" rtlCol="0" anchor="ctr"/>
           <a:lstStyle/>
           <a:p>
-            <a:pPr marL="0" indent="0" algn="l">
-              <a:buNone/>
-            </a:pPr>
-            <a:endParaRPr lang="en-US" sz="1100"/>
-            <a:r>
-              <a:rPr lang="en-US" dirty="0"/>
-              <a:t>Branch feature/migration-progress — key commits:</a:t>
-            </a:r>
-          </a:p>
-          <a:p>
-            <a:pPr marL="0" indent="0" algn="l">
-              <a:buNone/>
-            </a:pPr>
-            <a:endParaRPr lang="en-US" sz="1100"/>
-            <a:r>
-              <a:rPr lang="en-US" dirty="0"/>
-              <a:t>c168a01 (spec), ed438f4 (plan), 6a379e1 (pre-001 fix), fe083bc (Vue timing fix), 449adf0 (docs)</a:t>
+            <a:pPr marL="171450" indent="-171450" algn="l">
+              <a:buFont typeface="Arial" panose="020B0604020202020204" pitchFamily="34" charset="0"/>
+              <a:buChar char="•"/>
+            </a:pPr>
+            <a:r>
+              <a:rPr lang="en-US" sz="1200" dirty="0">
+                <a:solidFill>
+                  <a:srgbClr val="1B2227"/>
+                </a:solidFill>
+                <a:latin typeface="Arial" panose="020B0604020202020204" pitchFamily="34" charset="0"/>
+                <a:cs typeface="Arial" panose="020B0604020202020204" pitchFamily="34" charset="0"/>
+              </a:rPr>
+              <a:t>https://github.com/ajulian35/migration-cypress-to-playwright  (branch L2)</a:t>
+            </a:r>
+          </a:p>
+          <a:p>
+            <a:pPr marL="171450" indent="-171450" algn="l">
+              <a:buFont typeface="Arial" panose="020B0604020202020204" pitchFamily="34" charset="0"/>
+              <a:buChar char="•"/>
+            </a:pPr>
+            <a:r>
+              <a:rPr lang="en-US" sz="1200" dirty="0">
+                <a:solidFill>
+                  <a:srgbClr val="1B2227"/>
+                </a:solidFill>
+                <a:latin typeface="Arial" panose="020B0604020202020204" pitchFamily="34" charset="0"/>
+                <a:cs typeface="Arial" panose="020B0604020202020204" pitchFamily="34" charset="0"/>
+              </a:rPr>
+              <a:t>REFLECTION.md</a:t>
             </a:r>
           </a:p>
         </p:txBody>
@@ -12794,8 +13787,8 @@
         </p:nvSpPr>
         <p:spPr>
           <a:xfrm>
-            <a:off x="6675120" y="1417320"/>
-            <a:ext cx="2103120" cy="411480"/>
+            <a:off x="6591600" y="1411031"/>
+            <a:ext cx="2103120" cy="777240"/>
           </a:xfrm>
           <a:prstGeom prst="roundRect">
             <a:avLst>
@@ -12828,7 +13821,7 @@
         </p:nvSpPr>
         <p:spPr>
           <a:xfrm>
-            <a:off x="6784848" y="1417320"/>
+            <a:off x="6720228" y="1691532"/>
             <a:ext cx="1883664" cy="411480"/>
           </a:xfrm>
           <a:prstGeom prst="rect">
@@ -12841,34 +13834,53 @@
           <a:bodyPr wrap="square" rtlCol="0" anchor="ctr"/>
           <a:lstStyle/>
           <a:p>
-            <a:pPr marL="0" indent="0" algn="l">
-              <a:buNone/>
-            </a:pPr>
-            <a:endParaRPr lang="en-US" sz="1100"/>
-            <a:r>
-              <a:rPr lang="en-US" dirty="0"/>
-              <a:t>Demo recording descoped — session transcript JSONL serves as equivalent:</a:t>
-            </a:r>
-          </a:p>
-          <a:p>
-            <a:pPr marL="0" indent="0" algn="l">
-              <a:buNone/>
-            </a:pPr>
-            <a:endParaRPr lang="en-US" sz="1100"/>
-            <a:r>
-              <a:rPr lang="en-US" dirty="0"/>
-              <a:t>.claude-perficient/projects/.../9bd4ca8f-5ffd-4a63-9b14-d293401c8be2.jsonl</a:t>
-            </a:r>
-          </a:p>
-          <a:p>
-            <a:pPr marL="0" indent="0" algn="l">
-              <a:buNone/>
-            </a:pPr>
-            <a:endParaRPr lang="en-US" sz="1100"/>
-            <a:r>
-              <a:rPr lang="en-US" dirty="0"/>
-              <a:t>(238 tool calls, includes full Vue timing failure + recovery sequence)</a:t>
-            </a:r>
+            <a:pPr marL="171450" indent="-171450" algn="l">
+              <a:buFont typeface="Arial" panose="020B0604020202020204" pitchFamily="34" charset="0"/>
+              <a:buChar char="•"/>
+            </a:pPr>
+            <a:r>
+              <a:rPr lang="en-US" sz="1200" dirty="0">
+                <a:latin typeface="Arial" panose="020B0604020202020204" pitchFamily="34" charset="0"/>
+                <a:cs typeface="Arial" panose="020B0604020202020204" pitchFamily="34" charset="0"/>
+              </a:rPr>
+              <a:t>Demo recording descoped </a:t>
+            </a:r>
+          </a:p>
+          <a:p>
+            <a:pPr marL="171450" indent="-171450" algn="l">
+              <a:buFont typeface="Arial" panose="020B0604020202020204" pitchFamily="34" charset="0"/>
+              <a:buChar char="•"/>
+            </a:pPr>
+            <a:r>
+              <a:rPr lang="en-US" sz="1200" dirty="0">
+                <a:latin typeface="Arial" panose="020B0604020202020204" pitchFamily="34" charset="0"/>
+                <a:cs typeface="Arial" panose="020B0604020202020204" pitchFamily="34" charset="0"/>
+              </a:rPr>
+              <a:t>/docs</a:t>
+            </a:r>
+          </a:p>
+          <a:p>
+            <a:pPr marL="171450" indent="-171450" algn="l">
+              <a:buFont typeface="Arial" panose="020B0604020202020204" pitchFamily="34" charset="0"/>
+              <a:buChar char="•"/>
+            </a:pPr>
+            <a:r>
+              <a:rPr lang="en-US" sz="1200" dirty="0">
+                <a:latin typeface="Arial" panose="020B0604020202020204" pitchFamily="34" charset="0"/>
+                <a:cs typeface="Arial" panose="020B0604020202020204" pitchFamily="34" charset="0"/>
+              </a:rPr>
+              <a:t>Portkey – Next slide</a:t>
+            </a:r>
+            <a:br>
+              <a:rPr lang="en-US" sz="1200" dirty="0">
+                <a:latin typeface="Arial" panose="020B0604020202020204" pitchFamily="34" charset="0"/>
+                <a:cs typeface="Arial" panose="020B0604020202020204" pitchFamily="34" charset="0"/>
+              </a:rPr>
+            </a:br>
+            <a:endParaRPr lang="en-US" sz="1200" dirty="0">
+              <a:latin typeface="Arial" panose="020B0604020202020204" pitchFamily="34" charset="0"/>
+              <a:cs typeface="Arial" panose="020B0604020202020204" pitchFamily="34" charset="0"/>
+            </a:endParaRPr>
           </a:p>
         </p:txBody>
       </p:sp>
@@ -12880,7 +13892,7 @@
         </p:nvSpPr>
         <p:spPr>
           <a:xfrm>
-            <a:off x="457200" y="2286000"/>
+            <a:off x="411480" y="2520720"/>
             <a:ext cx="1920240" cy="365760"/>
           </a:xfrm>
           <a:prstGeom prst="rect">
@@ -12919,8 +13931,8 @@
         </p:nvSpPr>
         <p:spPr>
           <a:xfrm>
-            <a:off x="2423160" y="2286000"/>
-            <a:ext cx="2103120" cy="411480"/>
+            <a:off x="1862280" y="2520720"/>
+            <a:ext cx="2618280" cy="1188720"/>
           </a:xfrm>
           <a:prstGeom prst="roundRect">
             <a:avLst>
@@ -12953,8 +13965,8 @@
         </p:nvSpPr>
         <p:spPr>
           <a:xfrm>
-            <a:off x="2532888" y="2286000"/>
-            <a:ext cx="1883664" cy="411480"/>
+            <a:off x="1898856" y="2845440"/>
+            <a:ext cx="2581704" cy="411480"/>
           </a:xfrm>
           <a:prstGeom prst="rect">
             <a:avLst/>
@@ -12969,29 +13981,50 @@
             <a:pPr marL="0" indent="0" algn="l">
               <a:buNone/>
             </a:pPr>
-            <a:endParaRPr lang="en-US" sz="1100"/>
-            <a:r>
-              <a:rPr lang="en-US" dirty="0"/>
-              <a:t>prompts/phase1_cypress_generation.md</a:t>
-            </a:r>
-          </a:p>
-          <a:p>
-            <a:pPr marL="0" indent="0" algn="l">
-              <a:buNone/>
-            </a:pPr>
-            <a:endParaRPr lang="en-US" sz="1100"/>
-            <a:r>
-              <a:rPr lang="en-US" dirty="0"/>
-              <a:t>prompts/phase2_playwright_migration.md</a:t>
-            </a:r>
-          </a:p>
-          <a:p>
-            <a:pPr marL="0" indent="0" algn="l">
-              <a:buNone/>
-            </a:pPr>
-            <a:endParaRPr lang="en-US" sz="1100"/>
-            <a:r>
-              <a:rPr lang="en-US" dirty="0"/>
+            <a:r>
+              <a:rPr lang="en-US" sz="1200" dirty="0">
+                <a:latin typeface="Arial" panose="020B0604020202020204" pitchFamily="34" charset="0"/>
+                <a:cs typeface="Arial" panose="020B0604020202020204" pitchFamily="34" charset="0"/>
+              </a:rPr>
+              <a:t>Prompts:</a:t>
+            </a:r>
+          </a:p>
+          <a:p>
+            <a:pPr marL="171450" indent="-171450" algn="l">
+              <a:buFont typeface="Arial" panose="020B0604020202020204" pitchFamily="34" charset="0"/>
+              <a:buChar char="•"/>
+            </a:pPr>
+            <a:r>
+              <a:rPr lang="en-US" sz="1200" dirty="0">
+                <a:latin typeface="Arial" panose="020B0604020202020204" pitchFamily="34" charset="0"/>
+                <a:cs typeface="Arial" panose="020B0604020202020204" pitchFamily="34" charset="0"/>
+              </a:rPr>
+              <a:t>phase1_cypress_generation.md</a:t>
+            </a:r>
+          </a:p>
+          <a:p>
+            <a:pPr marL="171450" indent="-171450" algn="l">
+              <a:buFont typeface="Arial" panose="020B0604020202020204" pitchFamily="34" charset="0"/>
+              <a:buChar char="•"/>
+            </a:pPr>
+            <a:r>
+              <a:rPr lang="en-US" sz="1200" dirty="0">
+                <a:latin typeface="Arial" panose="020B0604020202020204" pitchFamily="34" charset="0"/>
+                <a:cs typeface="Arial" panose="020B0604020202020204" pitchFamily="34" charset="0"/>
+              </a:rPr>
+              <a:t>phase2_playwright_migration.m</a:t>
+            </a:r>
+          </a:p>
+          <a:p>
+            <a:pPr marL="171450" indent="-171450" algn="l">
+              <a:buFont typeface="Arial" panose="020B0604020202020204" pitchFamily="34" charset="0"/>
+              <a:buChar char="•"/>
+            </a:pPr>
+            <a:r>
+              <a:rPr lang="en-US" sz="1200" dirty="0">
+                <a:latin typeface="Arial" panose="020B0604020202020204" pitchFamily="34" charset="0"/>
+                <a:cs typeface="Arial" panose="020B0604020202020204" pitchFamily="34" charset="0"/>
+              </a:rPr>
               <a:t>.claude/agents/playwright-migration.md</a:t>
             </a:r>
           </a:p>
@@ -13005,7 +14038,7 @@
         </p:nvSpPr>
         <p:spPr>
           <a:xfrm>
-            <a:off x="4709160" y="2286000"/>
+            <a:off x="4663440" y="2520720"/>
             <a:ext cx="1920240" cy="365760"/>
           </a:xfrm>
           <a:prstGeom prst="rect">
@@ -13044,8 +14077,8 @@
         </p:nvSpPr>
         <p:spPr>
           <a:xfrm>
-            <a:off x="6675120" y="2286000"/>
-            <a:ext cx="2103120" cy="411480"/>
+            <a:off x="6629400" y="2520720"/>
+            <a:ext cx="2103120" cy="1188720"/>
           </a:xfrm>
           <a:prstGeom prst="roundRect">
             <a:avLst>
@@ -13078,7 +14111,7 @@
         </p:nvSpPr>
         <p:spPr>
           <a:xfrm>
-            <a:off x="6784848" y="2286000"/>
+            <a:off x="6739128" y="2859048"/>
             <a:ext cx="1883664" cy="411480"/>
           </a:xfrm>
           <a:prstGeom prst="rect">
@@ -13091,24 +14124,54 @@
           <a:bodyPr wrap="square" rtlCol="0" anchor="ctr"/>
           <a:lstStyle/>
           <a:p>
-            <a:pPr marL="0" indent="0" algn="l">
-              <a:buNone/>
-            </a:pPr>
-            <a:endParaRPr lang="en-US" sz="1100"/>
-            <a:r>
-              <a:rPr lang="en-US" dirty="0"/>
-              <a:t>reports/playwright/report.html — 8/8 passing, 82 s</a:t>
-            </a:r>
-          </a:p>
-          <a:p>
-            <a:pPr marL="0" indent="0" algn="l">
-              <a:buNone/>
-            </a:pPr>
-            <a:endParaRPr lang="en-US" sz="1100"/>
-            <a:r>
-              <a:rPr lang="en-US" dirty="0"/>
-              <a:t>reports/cypress/mochawesome_086-093.html — 8/8 passing, 1 m 43 s</a:t>
-            </a:r>
+            <a:pPr marL="171450" indent="-171450" algn="l">
+              <a:buFont typeface="Arial" panose="020B0604020202020204" pitchFamily="34" charset="0"/>
+              <a:buChar char="•"/>
+            </a:pPr>
+            <a:r>
+              <a:rPr lang="en-US" sz="1200" dirty="0">
+                <a:latin typeface="Arial" panose="020B0604020202020204" pitchFamily="34" charset="0"/>
+                <a:cs typeface="Arial" panose="020B0604020202020204" pitchFamily="34" charset="0"/>
+              </a:rPr>
+              <a:t>reports/playwright/report.html </a:t>
+            </a:r>
+          </a:p>
+          <a:p>
+            <a:pPr marL="171450" indent="-171450" algn="l">
+              <a:buFont typeface="Arial" panose="020B0604020202020204" pitchFamily="34" charset="0"/>
+              <a:buChar char="•"/>
+            </a:pPr>
+            <a:r>
+              <a:rPr lang="en-US" sz="1200" dirty="0">
+                <a:latin typeface="Arial" panose="020B0604020202020204" pitchFamily="34" charset="0"/>
+                <a:cs typeface="Arial" panose="020B0604020202020204" pitchFamily="34" charset="0"/>
+              </a:rPr>
+              <a:t>8/8 passing</a:t>
+            </a:r>
+          </a:p>
+          <a:p>
+            <a:pPr marL="171450" indent="-171450" algn="l">
+              <a:buFont typeface="Arial" panose="020B0604020202020204" pitchFamily="34" charset="0"/>
+              <a:buChar char="•"/>
+            </a:pPr>
+            <a:r>
+              <a:rPr lang="en-US" sz="1200" dirty="0">
+                <a:latin typeface="Arial" panose="020B0604020202020204" pitchFamily="34" charset="0"/>
+                <a:cs typeface="Arial" panose="020B0604020202020204" pitchFamily="34" charset="0"/>
+              </a:rPr>
+              <a:t>reports/cypress/</a:t>
+            </a:r>
+            <a:r>
+              <a:rPr lang="en-US" sz="1200" dirty="0" err="1">
+                <a:latin typeface="Arial" panose="020B0604020202020204" pitchFamily="34" charset="0"/>
+                <a:cs typeface="Arial" panose="020B0604020202020204" pitchFamily="34" charset="0"/>
+              </a:rPr>
+              <a:t>mochawesome</a:t>
+            </a:r>
+            <a:endParaRPr lang="en-US" sz="1200" dirty="0">
+              <a:latin typeface="Arial" panose="020B0604020202020204" pitchFamily="34" charset="0"/>
+              <a:cs typeface="Arial" panose="020B0604020202020204" pitchFamily="34" charset="0"/>
+            </a:endParaRPr>
           </a:p>
         </p:txBody>
       </p:sp>
@@ -13120,7 +14183,7 @@
         </p:nvSpPr>
         <p:spPr>
           <a:xfrm>
-            <a:off x="457200" y="3383280"/>
+            <a:off x="457200" y="3800880"/>
             <a:ext cx="8229600" cy="1234440"/>
           </a:xfrm>
           <a:prstGeom prst="roundRect">
@@ -13149,7 +14212,7 @@
         </p:nvSpPr>
         <p:spPr>
           <a:xfrm>
-            <a:off x="640080" y="3474720"/>
+            <a:off x="640080" y="3892320"/>
             <a:ext cx="7863840" cy="320040"/>
           </a:xfrm>
           <a:prstGeom prst="rect">
@@ -13188,7 +14251,7 @@
         </p:nvSpPr>
         <p:spPr>
           <a:xfrm>
-            <a:off x="640080" y="3794760"/>
+            <a:off x="640080" y="4212360"/>
             <a:ext cx="7863840" cy="274320"/>
           </a:xfrm>
           <a:prstGeom prst="rect">
@@ -13227,7 +14290,7 @@
         </p:nvSpPr>
         <p:spPr>
           <a:xfrm>
-            <a:off x="640080" y="4160520"/>
+            <a:off x="640080" y="4578120"/>
             <a:ext cx="7863840" cy="365760"/>
           </a:xfrm>
           <a:prstGeom prst="rect">
@@ -13932,6 +14995,15 @@
 </file>
 
 <file path=customXml/item1.xml><?xml version="1.0" encoding="utf-8"?>
+<?mso-contentType ?>
+<FormTemplates xmlns="http://schemas.microsoft.com/sharepoint/v3/contenttype/forms">
+  <Display>DocumentLibraryForm</Display>
+  <Edit>DocumentLibraryForm</Edit>
+  <New>DocumentLibraryForm</New>
+</FormTemplates>
+</file>
+
+<file path=customXml/item2.xml><?xml version="1.0" encoding="utf-8"?>
 <ct:contentTypeSchema xmlns:ct="http://schemas.microsoft.com/office/2006/metadata/contentType" xmlns:ma="http://schemas.microsoft.com/office/2006/metadata/properties/metaAttributes" ct:_="" ma:_="" ma:contentTypeName="Document" ma:contentTypeID="0x010100178BDE5FBDD49645B4C97074EE65F842" ma:contentTypeVersion="12" ma:contentTypeDescription="Create a new document." ma:contentTypeScope="" ma:versionID="5312b329c996433ceb2b53c55abbd94c">
   <xsd:schema xmlns:xsd="http://www.w3.org/2001/XMLSchema" xmlns:xs="http://www.w3.org/2001/XMLSchema" xmlns:p="http://schemas.microsoft.com/office/2006/metadata/properties" xmlns:ns2="726f94d6-fa4c-4578-9923-387e8e08487a" xmlns:ns3="7a392144-d9c7-4700-81e3-5d9ccc7560d2" targetNamespace="http://schemas.microsoft.com/office/2006/metadata/properties" ma:root="true" ma:fieldsID="4c00a87271a249586203d6baa24a7578" ns2:_="" ns3:_="">
     <xsd:import namespace="726f94d6-fa4c-4578-9923-387e8e08487a"/>
@@ -14132,15 +15204,6 @@
 </ct:contentTypeSchema>
 </file>
 
-<file path=customXml/item2.xml><?xml version="1.0" encoding="utf-8"?>
-<?mso-contentType ?>
-<FormTemplates xmlns="http://schemas.microsoft.com/sharepoint/v3/contenttype/forms">
-  <Display>DocumentLibraryForm</Display>
-  <Edit>DocumentLibraryForm</Edit>
-  <New>DocumentLibraryForm</New>
-</FormTemplates>
-</file>
-
 <file path=customXml/item3.xml><?xml version="1.0" encoding="utf-8"?>
 <p:properties xmlns:p="http://schemas.microsoft.com/office/2006/metadata/properties" xmlns:xsi="http://www.w3.org/2001/XMLSchema-instance" xmlns:pc="http://schemas.microsoft.com/office/infopath/2007/PartnerControls">
   <documentManagement>
@@ -14154,6 +15217,14 @@
 </file>
 
 <file path=customXml/itemProps1.xml><?xml version="1.0" encoding="utf-8"?>
+<ds:datastoreItem xmlns:ds="http://schemas.openxmlformats.org/officeDocument/2006/customXml" ds:itemID="{D68DD810-7AED-43B6-BB17-F254283372F2}">
+  <ds:schemaRefs>
+    <ds:schemaRef ds:uri="http://schemas.microsoft.com/sharepoint/v3/contenttype/forms"/>
+  </ds:schemaRefs>
+</ds:datastoreItem>
+</file>
+
+<file path=customXml/itemProps2.xml><?xml version="1.0" encoding="utf-8"?>
 <ds:datastoreItem xmlns:ds="http://schemas.openxmlformats.org/officeDocument/2006/customXml" ds:itemID="{22674E81-17EB-43AD-A4DC-3DD0F2DF9E2A}">
   <ds:schemaRefs>
     <ds:schemaRef ds:uri="726f94d6-fa4c-4578-9923-387e8e08487a"/>
@@ -14168,14 +15239,6 @@
     <ds:schemaRef ds:uri="http://schemas.microsoft.com/office/infopath/2007/PartnerControls"/>
     <ds:schemaRef ds:uri="http://schemas.openxmlformats.org/package/2006/metadata/core-properties"/>
     <ds:schemaRef ds:uri="http://www.w3.org/2001/XMLSchema"/>
-  </ds:schemaRefs>
-</ds:datastoreItem>
-</file>
-
-<file path=customXml/itemProps2.xml><?xml version="1.0" encoding="utf-8"?>
-<ds:datastoreItem xmlns:ds="http://schemas.openxmlformats.org/officeDocument/2006/customXml" ds:itemID="{D68DD810-7AED-43B6-BB17-F254283372F2}">
-  <ds:schemaRefs>
-    <ds:schemaRef ds:uri="http://schemas.microsoft.com/sharepoint/v3/contenttype/forms"/>
   </ds:schemaRefs>
 </ds:datastoreItem>
 </file>

</xml_diff>